<commit_message>
Add Genistein, Daidzein, Glycitein isoflavones to App, Presentation, and Fallback Dataset
</commit_message>
<xml_diff>
--- a/Presentasi_PharmaPulse_3D.pptx
+++ b/Presentasi_PharmaPulse_3D.pptx
@@ -5279,7 +5279,7 @@
               </a:defRPr>
             </a:pPr>
             <a:r>
-              <a:t>Contoh Studi Kasus Pengujian Obat</a:t>
+              <a:t>Studi Kasus Isoflavon Kedelai: Genistein, Daidzein &amp; Glycitein</a:t>
             </a:r>
           </a:p>
         </p:txBody>
@@ -5382,7 +5382,7 @@
               </a:defRPr>
             </a:pPr>
             <a:r>
-              <a:t>Paracetamol (CID 1983)</a:t>
+              <a:t>Genistein (CID 5280961)</a:t>
             </a:r>
           </a:p>
           <a:p>
@@ -5398,7 +5398,7 @@
               </a:defRPr>
             </a:pPr>
             <a:r>
-              <a:t>MW: 151.16 g/mol</a:t>
+              <a:t>Formula: C15H10O5</a:t>
             </a:r>
           </a:p>
           <a:p>
@@ -5414,7 +5414,7 @@
               </a:defRPr>
             </a:pPr>
             <a:r>
-              <a:t>LogP: 0.5</a:t>
+              <a:t>MW: 270.24 g/mol | LogP: 2.7</a:t>
             </a:r>
           </a:p>
           <a:p>
@@ -5430,7 +5430,7 @@
               </a:defRPr>
             </a:pPr>
             <a:r>
-              <a:t>HBD: 2 | HBA: 2</a:t>
+              <a:t>HBD: 3 | HBA: 5</a:t>
             </a:r>
           </a:p>
           <a:p>
@@ -5446,7 +5446,7 @@
               </a:defRPr>
             </a:pPr>
             <a:r>
-              <a:t>TPSA: 49.33 Å²</a:t>
+              <a:t>TPSA: 87.00 Å² | RotB: 1</a:t>
             </a:r>
           </a:p>
           <a:p>
@@ -5491,7 +5491,7 @@
               </a:defRPr>
             </a:pPr>
             <a:r>
-              <a:t>Verdict: Sangat potensial sebagai sediaan oral (0 Pelanggaran).</a:t>
+              <a:t>Verdict: Isoflavon kedelai utama dengan kelayakan penyerapan oral 100% ideal.</a:t>
             </a:r>
           </a:p>
         </p:txBody>
@@ -5543,13 +5543,13 @@
               </a:spcAft>
               <a:defRPr sz="1600" b="1">
                 <a:solidFill>
-                  <a:srgbClr val="F59E0B"/>
+                  <a:srgbClr val="10B981"/>
                 </a:solidFill>
                 <a:latin typeface="Arial"/>
               </a:defRPr>
             </a:pPr>
             <a:r>
-              <a:t>Atorvastatin (CID 60823)</a:t>
+              <a:t>Daidzein (CID 5281708)</a:t>
             </a:r>
           </a:p>
           <a:p>
@@ -5565,7 +5565,7 @@
               </a:defRPr>
             </a:pPr>
             <a:r>
-              <a:t>MW: 558.64 g/mol</a:t>
+              <a:t>Formula: C15H10O4</a:t>
             </a:r>
           </a:p>
           <a:p>
@@ -5581,7 +5581,7 @@
               </a:defRPr>
             </a:pPr>
             <a:r>
-              <a:t>LogP: 5.7</a:t>
+              <a:t>MW: 254.24 g/mol | LogP: 2.5</a:t>
             </a:r>
           </a:p>
           <a:p>
@@ -5597,7 +5597,7 @@
               </a:defRPr>
             </a:pPr>
             <a:r>
-              <a:t>HBD: 4 | HBA: 7</a:t>
+              <a:t>HBD: 2 | HBA: 4</a:t>
             </a:r>
           </a:p>
           <a:p>
@@ -5613,7 +5613,7 @@
               </a:defRPr>
             </a:pPr>
             <a:r>
-              <a:t>TPSA: 111.53 Å²</a:t>
+              <a:t>TPSA: 66.80 Å² | RotB: 1</a:t>
             </a:r>
           </a:p>
           <a:p>
@@ -5642,7 +5642,7 @@
               </a:defRPr>
             </a:pPr>
             <a:r>
-              <a:t>Skor RO5: 2/4 (Peringatan)</a:t>
+              <a:t>Skor RO5: 4/4 (Lolos)</a:t>
             </a:r>
           </a:p>
           <a:p>
@@ -5658,7 +5658,7 @@
               </a:defRPr>
             </a:pPr>
             <a:r>
-              <a:t>Verdict: Melanggar 2 aturan (MW &gt; 500 &amp; LogP &gt; 5).</a:t>
+              <a:t>Verdict: Prekursor metabolit equol bioaktif dengan profil lipofilitas tinggi.</a:t>
             </a:r>
           </a:p>
         </p:txBody>
@@ -5716,7 +5716,7 @@
               </a:defRPr>
             </a:pPr>
             <a:r>
-              <a:t>Amoxicillin (CID 33613)</a:t>
+              <a:t>Glycitein (CID 5317750)</a:t>
             </a:r>
           </a:p>
           <a:p>
@@ -5732,7 +5732,7 @@
               </a:defRPr>
             </a:pPr>
             <a:r>
-              <a:t>MW: 365.40 g/mol</a:t>
+              <a:t>Formula: C16H12O5</a:t>
             </a:r>
           </a:p>
           <a:p>
@@ -5748,7 +5748,7 @@
               </a:defRPr>
             </a:pPr>
             <a:r>
-              <a:t>LogP: -2.0</a:t>
+              <a:t>MW: 284.26 g/mol | LogP: 2.4</a:t>
             </a:r>
           </a:p>
           <a:p>
@@ -5764,7 +5764,7 @@
               </a:defRPr>
             </a:pPr>
             <a:r>
-              <a:t>HBD: 4 | HBA: 6</a:t>
+              <a:t>HBD: 2 | HBA: 5</a:t>
             </a:r>
           </a:p>
           <a:p>
@@ -5780,7 +5780,7 @@
               </a:defRPr>
             </a:pPr>
             <a:r>
-              <a:t>TPSA: 158.00 Å²</a:t>
+              <a:t>TPSA: 76.00 Å² | RotB: 2</a:t>
             </a:r>
           </a:p>
           <a:p>
@@ -5825,7 +5825,7 @@
               </a:defRPr>
             </a:pPr>
             <a:r>
-              <a:t>Verdict: Lolos ideal sebagai antibiotik oral.</a:t>
+              <a:t>Verdict: Metoksidisoflavon alami yang memenuhi seluruh kriteria Lipinski RO5.</a:t>
             </a:r>
           </a:p>
         </p:txBody>

</xml_diff>

<commit_message>
Major Academic Upgrade: ChEMBL QSAR Modeling, SwissADME Radar, PAINS Alerts, BCS Ionization, & SwissADME Validation Table
</commit_message>
<xml_diff>
--- a/Presentasi_PharmaPulse_3D.pptx
+++ b/Presentasi_PharmaPulse_3D.pptx
@@ -13,6 +13,8 @@
     <p:sldId id="261" r:id="rId12"/>
     <p:sldId id="262" r:id="rId13"/>
     <p:sldId id="263" r:id="rId14"/>
+    <p:sldId id="264" r:id="rId15"/>
+    <p:sldId id="265" r:id="rId16"/>
   </p:sldIdLst>
   <p:sldSz cx="12191695" cy="6858000" type="screen4x3"/>
   <p:notesSz cx="6858000" cy="9144000"/>
@@ -3153,7 +3155,7 @@
               </a:defRPr>
             </a:pPr>
             <a:r>
-              <a:t>PubChem Powered Drug Discovery &amp; QSAR Physicochemical Analyzer</a:t>
+              <a:t>Pemodelan QSAR ChEMBL, ADMET, &amp; Druglikeness Physicochemical Profiler</a:t>
             </a:r>
           </a:p>
           <a:p>
@@ -3169,7 +3171,7 @@
               </a:defRPr>
             </a:pPr>
             <a:r>
-              <a:t>Aplikasi Berbasis Web untuk Penapisan Kelayakan Obat (Druglikeness), Evaluasi Lipinski RO5, &amp; Visualisasi 3D Konformer Molekul secara Real-Time.</a:t>
+              <a:t>Aplikasi Berbasis Web untuk Regresi Linier Bioaktivitas (pIC50), Saringan PAINS/Brenk, Ionisasi BCS, &amp; Visualisasi 3D Konformer Molekul.</a:t>
             </a:r>
           </a:p>
           <a:p>
@@ -3218,7 +3220,350 @@
               </a:defRPr>
             </a:pPr>
             <a:r>
-              <a:t>PharmaPulse 3D - Presentasi Akademis | Slide 1 dari 8</a:t>
+              <a:t>PharmaPulse 3D - Presentasi Komprehensif Akademis | Slide 1 dari 10</a:t>
+            </a:r>
+          </a:p>
+        </p:txBody>
+      </p:sp>
+    </p:spTree>
+  </p:cSld>
+  <p:clrMapOvr>
+    <a:masterClrMapping/>
+  </p:clrMapOvr>
+</p:sld>
+</file>
+
+<file path=ppt/slides/slide10.xml><?xml version="1.0" encoding="utf-8"?>
+<p:sld xmlns:a="http://schemas.openxmlformats.org/drawingml/2006/main" xmlns:p="http://schemas.openxmlformats.org/presentationml/2006/main" xmlns:r="http://schemas.openxmlformats.org/officeDocument/2006/relationships">
+  <p:cSld>
+    <p:bg>
+      <p:bgPr>
+        <a:solidFill>
+          <a:srgbClr val="090D16"/>
+        </a:solidFill>
+        <a:effectLst/>
+      </p:bgPr>
+    </p:bg>
+    <p:spTree>
+      <p:nvGrpSpPr>
+        <p:cNvPr id="1" name=""/>
+        <p:cNvGrpSpPr/>
+        <p:nvPr/>
+      </p:nvGrpSpPr>
+      <p:grpSpPr/>
+      <p:sp>
+        <p:nvSpPr>
+          <p:cNvPr id="2" name="TextBox 1"/>
+          <p:cNvSpPr txBox="1"/>
+          <p:nvPr/>
+        </p:nvSpPr>
+        <p:spPr>
+          <a:xfrm>
+            <a:off x="731520" y="365760"/>
+            <a:ext cx="3657600" cy="365760"/>
+          </a:xfrm>
+          <a:prstGeom prst="rect">
+            <a:avLst/>
+          </a:prstGeom>
+          <a:noFill/>
+        </p:spPr>
+        <p:txBody>
+          <a:bodyPr wrap="square">
+            <a:spAutoFit/>
+          </a:bodyPr>
+          <a:lstStyle/>
+          <a:p>
+            <a:pPr>
+              <a:defRPr sz="1000" b="1">
+                <a:solidFill>
+                  <a:srgbClr val="06B6D4"/>
+                </a:solidFill>
+                <a:latin typeface="Trebuchet MS"/>
+              </a:defRPr>
+            </a:pPr>
+            <a:r>
+              <a:t>PRESENTASI PROYEK KIMIA FARMASI</a:t>
+            </a:r>
+          </a:p>
+        </p:txBody>
+      </p:sp>
+      <p:sp>
+        <p:nvSpPr>
+          <p:cNvPr id="3" name="TextBox 2"/>
+          <p:cNvSpPr txBox="1"/>
+          <p:nvPr/>
+        </p:nvSpPr>
+        <p:spPr>
+          <a:xfrm>
+            <a:off x="731520" y="640080"/>
+            <a:ext cx="10698480" cy="731520"/>
+          </a:xfrm>
+          <a:prstGeom prst="rect">
+            <a:avLst/>
+          </a:prstGeom>
+          <a:noFill/>
+        </p:spPr>
+        <p:txBody>
+          <a:bodyPr wrap="none">
+            <a:spAutoFit/>
+          </a:bodyPr>
+          <a:lstStyle/>
+          <a:p>
+            <a:pPr>
+              <a:defRPr sz="2400" b="1">
+                <a:solidFill>
+                  <a:srgbClr val="F8FAFC"/>
+                </a:solidFill>
+                <a:latin typeface="Arial"/>
+              </a:defRPr>
+            </a:pPr>
+            <a:r>
+              <a:t>Kesimpulan &amp; Repositori Project</a:t>
+            </a:r>
+          </a:p>
+        </p:txBody>
+      </p:sp>
+      <p:sp>
+        <p:nvSpPr>
+          <p:cNvPr id="4" name="Rectangle 3"/>
+          <p:cNvSpPr/>
+          <p:nvPr/>
+        </p:nvSpPr>
+        <p:spPr>
+          <a:xfrm>
+            <a:off x="731520" y="1371600"/>
+            <a:ext cx="10728655" cy="18288"/>
+          </a:xfrm>
+          <a:prstGeom prst="rect">
+            <a:avLst/>
+          </a:prstGeom>
+          <a:solidFill>
+            <a:srgbClr val="1E293B"/>
+          </a:solidFill>
+          <a:ln>
+            <a:solidFill>
+              <a:srgbClr val="1E293B"/>
+            </a:solidFill>
+          </a:ln>
+        </p:spPr>
+        <p:style>
+          <a:lnRef idx="1">
+            <a:schemeClr val="accent1"/>
+          </a:lnRef>
+          <a:fillRef idx="3">
+            <a:schemeClr val="accent1"/>
+          </a:fillRef>
+          <a:effectRef idx="2">
+            <a:schemeClr val="accent1"/>
+          </a:effectRef>
+          <a:fontRef idx="minor">
+            <a:schemeClr val="lt1"/>
+          </a:fontRef>
+        </p:style>
+        <p:txBody>
+          <a:bodyPr rtlCol="0" anchor="ctr"/>
+          <a:lstStyle/>
+          <a:p>
+            <a:pPr algn="ctr"/>
+          </a:p>
+        </p:txBody>
+      </p:sp>
+      <p:sp>
+        <p:nvSpPr>
+          <p:cNvPr id="5" name="Rounded Rectangle 4"/>
+          <p:cNvSpPr/>
+          <p:nvPr/>
+        </p:nvSpPr>
+        <p:spPr>
+          <a:xfrm>
+            <a:off x="731520" y="1828800"/>
+            <a:ext cx="10728655" cy="4114800"/>
+          </a:xfrm>
+          <a:prstGeom prst="roundRect">
+            <a:avLst/>
+          </a:prstGeom>
+          <a:solidFill>
+            <a:srgbClr val="111827"/>
+          </a:solidFill>
+          <a:ln w="12700">
+            <a:solidFill>
+              <a:srgbClr val="1E293B"/>
+            </a:solidFill>
+          </a:ln>
+        </p:spPr>
+        <p:style>
+          <a:lnRef idx="1">
+            <a:schemeClr val="accent1"/>
+          </a:lnRef>
+          <a:fillRef idx="3">
+            <a:schemeClr val="accent1"/>
+          </a:fillRef>
+          <a:effectRef idx="2">
+            <a:schemeClr val="accent1"/>
+          </a:effectRef>
+          <a:fontRef idx="minor">
+            <a:schemeClr val="lt1"/>
+          </a:fontRef>
+        </p:style>
+        <p:txBody>
+          <a:bodyPr rtlCol="0" anchor="t" wrap="square" lIns="228600" rIns="228600" tIns="182880" bIns="182880"/>
+          <a:lstStyle/>
+          <a:p>
+            <a:pPr algn="ctr">
+              <a:spcAft>
+                <a:spcPts val="800"/>
+              </a:spcAft>
+              <a:defRPr sz="1600" b="1">
+                <a:solidFill>
+                  <a:srgbClr val="06B6D4"/>
+                </a:solidFill>
+                <a:latin typeface="Arial"/>
+              </a:defRPr>
+            </a:pPr>
+            <a:r>
+              <a:t>PharmaPulse 3D Siap Digunakan &amp; Teruji Akademis</a:t>
+            </a:r>
+          </a:p>
+          <a:p>
+            <a:pPr>
+              <a:spcAft>
+                <a:spcPts val="600"/>
+              </a:spcAft>
+              <a:defRPr sz="1200">
+                <a:solidFill>
+                  <a:srgbClr val="94A3B8"/>
+                </a:solidFill>
+                <a:latin typeface="Calibri"/>
+              </a:defRPr>
+            </a:pPr>
+            <a:r>
+              <a:t>• PharmaPulse 3D telah memenuhi standar komputasi QSAR ChEMBL, saringan PAINS/Brenk, ionisasi BCS, dan evaluasi Lipinski RO5.</a:t>
+            </a:r>
+          </a:p>
+          <a:p>
+            <a:pPr>
+              <a:spcAft>
+                <a:spcPts val="600"/>
+              </a:spcAft>
+              <a:defRPr sz="1200">
+                <a:solidFill>
+                  <a:srgbClr val="94A3B8"/>
+                </a:solidFill>
+                <a:latin typeface="Calibri"/>
+              </a:defRPr>
+            </a:pPr>
+            <a:r>
+              <a:t>• Terbukti presisi melalui validasi terhadap SwissADME SIB.</a:t>
+            </a:r>
+          </a:p>
+          <a:p>
+            <a:pPr>
+              <a:spcAft>
+                <a:spcPts val="600"/>
+              </a:spcAft>
+              <a:defRPr sz="1200">
+                <a:solidFill>
+                  <a:srgbClr val="94A3B8"/>
+                </a:solidFill>
+                <a:latin typeface="Calibri"/>
+              </a:defRPr>
+            </a:pPr>
+          </a:p>
+          <a:p>
+            <a:pPr>
+              <a:spcAft>
+                <a:spcPts val="600"/>
+              </a:spcAft>
+              <a:defRPr sz="1200">
+                <a:solidFill>
+                  <a:srgbClr val="94A3B8"/>
+                </a:solidFill>
+                <a:latin typeface="Calibri"/>
+              </a:defRPr>
+            </a:pPr>
+            <a:r>
+              <a:t>GitHub Repository: https://github.com/novarani1511/pharmapulse-3d</a:t>
+            </a:r>
+          </a:p>
+          <a:p>
+            <a:pPr>
+              <a:spcAft>
+                <a:spcPts val="600"/>
+              </a:spcAft>
+              <a:defRPr sz="1200">
+                <a:solidFill>
+                  <a:srgbClr val="94A3B8"/>
+                </a:solidFill>
+                <a:latin typeface="Calibri"/>
+              </a:defRPr>
+            </a:pPr>
+            <a:r>
+              <a:t>Demo Server Lokal: http://localhost:3000</a:t>
+            </a:r>
+          </a:p>
+          <a:p>
+            <a:pPr>
+              <a:spcAft>
+                <a:spcPts val="600"/>
+              </a:spcAft>
+              <a:defRPr sz="1200">
+                <a:solidFill>
+                  <a:srgbClr val="94A3B8"/>
+                </a:solidFill>
+                <a:latin typeface="Calibri"/>
+              </a:defRPr>
+            </a:pPr>
+          </a:p>
+          <a:p>
+            <a:pPr>
+              <a:spcAft>
+                <a:spcPts val="600"/>
+              </a:spcAft>
+              <a:defRPr sz="1200">
+                <a:solidFill>
+                  <a:srgbClr val="94A3B8"/>
+                </a:solidFill>
+                <a:latin typeface="Calibri"/>
+              </a:defRPr>
+            </a:pPr>
+            <a:r>
+              <a:t>Terima kasih atas masukan &amp; bimbingan Bapak/Ibu Dosen!</a:t>
+            </a:r>
+          </a:p>
+        </p:txBody>
+      </p:sp>
+      <p:sp>
+        <p:nvSpPr>
+          <p:cNvPr id="6" name="TextBox 5"/>
+          <p:cNvSpPr txBox="1"/>
+          <p:nvPr/>
+        </p:nvSpPr>
+        <p:spPr>
+          <a:xfrm>
+            <a:off x="731520" y="6309360"/>
+            <a:ext cx="10728655" cy="365760"/>
+          </a:xfrm>
+          <a:prstGeom prst="rect">
+            <a:avLst/>
+          </a:prstGeom>
+          <a:noFill/>
+        </p:spPr>
+        <p:txBody>
+          <a:bodyPr wrap="none">
+            <a:spAutoFit/>
+          </a:bodyPr>
+          <a:lstStyle/>
+          <a:p>
+            <a:pPr>
+              <a:defRPr sz="1000">
+                <a:solidFill>
+                  <a:srgbClr val="94A3B8"/>
+                </a:solidFill>
+                <a:latin typeface="Calibri"/>
+              </a:defRPr>
+            </a:pPr>
+            <a:r>
+              <a:t>PharmaPulse 3D - Presentasi Komprehensif Akademis | Slide 10 dari 10</a:t>
             </a:r>
           </a:p>
         </p:txBody>
@@ -3316,7 +3661,7 @@
               </a:defRPr>
             </a:pPr>
             <a:r>
-              <a:t>Latar Belakang &amp; Urgensi Penelitian</a:t>
+              <a:t>Latar Belakang &amp; Pemodelan QSAR Real Data</a:t>
             </a:r>
           </a:p>
         </p:txBody>
@@ -3419,39 +3764,39 @@
               </a:defRPr>
             </a:pPr>
             <a:r>
-              <a:t>Tantangan Desain Obat Klasik</a:t>
-            </a:r>
-          </a:p>
-          <a:p>
-            <a:pPr>
-              <a:spcAft>
-                <a:spcPts val="600"/>
-              </a:spcAft>
-              <a:defRPr sz="1200">
-                <a:solidFill>
-                  <a:srgbClr val="94A3B8"/>
-                </a:solidFill>
-                <a:latin typeface="Calibri"/>
-              </a:defRPr>
-            </a:pPr>
-            <a:r>
-              <a:t>Proses penemuan obat membutuhkan biaya tinggi dan waktu bertahun-tahun.</a:t>
-            </a:r>
-          </a:p>
-          <a:p>
-            <a:pPr>
-              <a:spcAft>
-                <a:spcPts val="600"/>
-              </a:spcAft>
-              <a:defRPr sz="1200">
-                <a:solidFill>
-                  <a:srgbClr val="94A3B8"/>
-                </a:solidFill>
-                <a:latin typeface="Calibri"/>
-              </a:defRPr>
-            </a:pPr>
-            <a:r>
-              <a:t>Banyak calon molekul obat gagal pada uji klinis akibat sifat permeabilitas dan absorpsi oral yang buruk.</a:t>
+              <a:t>Integrasi Pemodelan QSAR ChEMBL</a:t>
+            </a:r>
+          </a:p>
+          <a:p>
+            <a:pPr>
+              <a:spcAft>
+                <a:spcPts val="600"/>
+              </a:spcAft>
+              <a:defRPr sz="1200">
+                <a:solidFill>
+                  <a:srgbClr val="94A3B8"/>
+                </a:solidFill>
+                <a:latin typeface="Calibri"/>
+              </a:defRPr>
+            </a:pPr>
+            <a:r>
+              <a:t>Menghubungkan deskriptor fisikokimia (XLogP/TPSA) dengan bioaktivitas nyata (pIC50 = -log IC50).</a:t>
+            </a:r>
+          </a:p>
+          <a:p>
+            <a:pPr>
+              <a:spcAft>
+                <a:spcPts val="600"/>
+              </a:spcAft>
+              <a:defRPr sz="1200">
+                <a:solidFill>
+                  <a:srgbClr val="94A3B8"/>
+                </a:solidFill>
+                <a:latin typeface="Calibri"/>
+              </a:defRPr>
+            </a:pPr>
+            <a:r>
+              <a:t>Pemetaaan otomatis melalui InChIKey unik untuk mencegah ambiguitas penamaan obat.</a:t>
             </a:r>
           </a:p>
         </p:txBody>
@@ -3509,39 +3854,39 @@
               </a:defRPr>
             </a:pPr>
             <a:r>
-              <a:t>Peran Aturan Lipinski (RO5)</a:t>
-            </a:r>
-          </a:p>
-          <a:p>
-            <a:pPr>
-              <a:spcAft>
-                <a:spcPts val="600"/>
-              </a:spcAft>
-              <a:defRPr sz="1200">
-                <a:solidFill>
-                  <a:srgbClr val="94A3B8"/>
-                </a:solidFill>
-                <a:latin typeface="Calibri"/>
-              </a:defRPr>
-            </a:pPr>
-            <a:r>
-              <a:t>Christopher A. Lipinski merumuskan Aturan Empat Parameter (Lipinski's Rule of Five).</a:t>
-            </a:r>
-          </a:p>
-          <a:p>
-            <a:pPr>
-              <a:spcAft>
-                <a:spcPts val="600"/>
-              </a:spcAft>
-              <a:defRPr sz="1200">
-                <a:solidFill>
-                  <a:srgbClr val="94A3B8"/>
-                </a:solidFill>
-                <a:latin typeface="Calibri"/>
-              </a:defRPr>
-            </a:pPr>
-            <a:r>
-              <a:t>Digunakan untuk memprediksi secara cepat permeabilitas membran sel dan bioavailabilitas oral molekul.</a:t>
+              <a:t>Pentingnya Saringan PAINS &amp; Brenk</a:t>
+            </a:r>
+          </a:p>
+          <a:p>
+            <a:pPr>
+              <a:spcAft>
+                <a:spcPts val="600"/>
+              </a:spcAft>
+              <a:defRPr sz="1200">
+                <a:solidFill>
+                  <a:srgbClr val="94A3B8"/>
+                </a:solidFill>
+                <a:latin typeface="Calibri"/>
+              </a:defRPr>
+            </a:pPr>
+            <a:r>
+              <a:t>Deteksi dini gugus molekul bernoda (Pan-Assay Interference Compounds).</a:t>
+            </a:r>
+          </a:p>
+          <a:p>
+            <a:pPr>
+              <a:spcAft>
+                <a:spcPts val="600"/>
+              </a:spcAft>
+              <a:defRPr sz="1200">
+                <a:solidFill>
+                  <a:srgbClr val="94A3B8"/>
+                </a:solidFill>
+                <a:latin typeface="Calibri"/>
+              </a:defRPr>
+            </a:pPr>
+            <a:r>
+              <a:t>Mencegah pembacaan positif palsu pada pengujian penapisan obat.</a:t>
             </a:r>
           </a:p>
         </p:txBody>
@@ -3599,39 +3944,39 @@
               </a:defRPr>
             </a:pPr>
             <a:r>
-              <a:t>Kebutuhan Akses Data Real-Time</a:t>
-            </a:r>
-          </a:p>
-          <a:p>
-            <a:pPr>
-              <a:spcAft>
-                <a:spcPts val="600"/>
-              </a:spcAft>
-              <a:defRPr sz="1200">
-                <a:solidFill>
-                  <a:srgbClr val="94A3B8"/>
-                </a:solidFill>
-                <a:latin typeface="Calibri"/>
-              </a:defRPr>
-            </a:pPr>
-            <a:r>
-              <a:t>Laboratorium akademis &amp; R&amp;D industri membutuhkan alat bantu komputasi cepat.</a:t>
-            </a:r>
-          </a:p>
-          <a:p>
-            <a:pPr>
-              <a:spcAft>
-                <a:spcPts val="600"/>
-              </a:spcAft>
-              <a:defRPr sz="1200">
-                <a:solidFill>
-                  <a:srgbClr val="94A3B8"/>
-                </a:solidFill>
-                <a:latin typeface="Calibri"/>
-              </a:defRPr>
-            </a:pPr>
-            <a:r>
-              <a:t>Terhubung langsung dengan basis data molekul ilmiah tanpa perlu menginput parameter manual.</a:t>
+              <a:t>Sistem Klasifikasi Biofarmasetika (BCS)</a:t>
+            </a:r>
+          </a:p>
+          <a:p>
+            <a:pPr>
+              <a:spcAft>
+                <a:spcPts val="600"/>
+              </a:spcAft>
+              <a:defRPr sz="1200">
+                <a:solidFill>
+                  <a:srgbClr val="94A3B8"/>
+                </a:solidFill>
+                <a:latin typeface="Calibri"/>
+              </a:defRPr>
+            </a:pPr>
+            <a:r>
+              <a:t>Memetakan kelarutan dan permeabilitas fisiologis (BCS Kelas I s/d IV).</a:t>
+            </a:r>
+          </a:p>
+          <a:p>
+            <a:pPr>
+              <a:spcAft>
+                <a:spcPts val="600"/>
+              </a:spcAft>
+              <a:defRPr sz="1200">
+                <a:solidFill>
+                  <a:srgbClr val="94A3B8"/>
+                </a:solidFill>
+                <a:latin typeface="Calibri"/>
+              </a:defRPr>
+            </a:pPr>
+            <a:r>
+              <a:t>Ionisasi Henderson-Hasselbalch pada pH lambung (1.2) dan darah/usus (7.4).</a:t>
             </a:r>
           </a:p>
         </p:txBody>
@@ -3689,39 +4034,39 @@
               </a:defRPr>
             </a:pPr>
             <a:r>
-              <a:t>Pentingnya Spatial 3D Conformer</a:t>
-            </a:r>
-          </a:p>
-          <a:p>
-            <a:pPr>
-              <a:spcAft>
-                <a:spcPts val="600"/>
-              </a:spcAft>
-              <a:defRPr sz="1200">
-                <a:solidFill>
-                  <a:srgbClr val="94A3B8"/>
-                </a:solidFill>
-                <a:latin typeface="Calibri"/>
-              </a:defRPr>
-            </a:pPr>
-            <a:r>
-              <a:t>Pemahaman spasial 3D molekul (panjang ikatan, gugus fungsi, dan kepolaran ruang).</a:t>
-            </a:r>
-          </a:p>
-          <a:p>
-            <a:pPr>
-              <a:spcAft>
-                <a:spcPts val="600"/>
-              </a:spcAft>
-              <a:defRPr sz="1200">
-                <a:solidFill>
-                  <a:srgbClr val="94A3B8"/>
-                </a:solidFill>
-                <a:latin typeface="Calibri"/>
-              </a:defRPr>
-            </a:pPr>
-            <a:r>
-              <a:t>Sangat vital dalam memprediksi interaksi molekul obat dengan reseptor biologis target.</a:t>
+              <a:t>Konteks Pengecualian Beyond RO5 (bRO5)</a:t>
+            </a:r>
+          </a:p>
+          <a:p>
+            <a:pPr>
+              <a:spcAft>
+                <a:spcPts val="600"/>
+              </a:spcAft>
+              <a:defRPr sz="1200">
+                <a:solidFill>
+                  <a:srgbClr val="94A3B8"/>
+                </a:solidFill>
+                <a:latin typeface="Calibri"/>
+              </a:defRPr>
+            </a:pPr>
+            <a:r>
+              <a:t>Memberikan pemahaman akademik bahwa pelanggaran RO5 tidak berarti gagal.</a:t>
+            </a:r>
+          </a:p>
+          <a:p>
+            <a:pPr>
+              <a:spcAft>
+                <a:spcPts val="600"/>
+              </a:spcAft>
+              <a:defRPr sz="1200">
+                <a:solidFill>
+                  <a:srgbClr val="94A3B8"/>
+                </a:solidFill>
+                <a:latin typeface="Calibri"/>
+              </a:defRPr>
+            </a:pPr>
+            <a:r>
+              <a:t>Produk alam (isoflavon kedelai) &amp; substrat transporter aktif (atorvastatin) berhasil sebagai obat oral.</a:t>
             </a:r>
           </a:p>
         </p:txBody>
@@ -3757,7 +4102,7 @@
               </a:defRPr>
             </a:pPr>
             <a:r>
-              <a:t>PharmaPulse 3D - Presentasi Akademis | Slide 2 dari 8</a:t>
+              <a:t>PharmaPulse 3D - Presentasi Komprehensif Akademis | Slide 2 dari 10</a:t>
             </a:r>
           </a:p>
         </p:txBody>
@@ -3855,7 +4200,7 @@
               </a:defRPr>
             </a:pPr>
             <a:r>
-              <a:t>Solusi &amp; Inovasi Teknologi PharmaPulse 3D</a:t>
+              <a:t>Modul Pemodelan QSAR (ChEMBL Bioactivity Regression)</a:t>
             </a:r>
           </a:p>
         </p:txBody>
@@ -3914,7 +4259,7 @@
         <p:spPr>
           <a:xfrm>
             <a:off x="731520" y="1828800"/>
-            <a:ext cx="3291840" cy="4114800"/>
+            <a:ext cx="5120640" cy="4114800"/>
           </a:xfrm>
           <a:prstGeom prst="roundRect">
             <a:avLst/>
@@ -3958,55 +4303,84 @@
               </a:defRPr>
             </a:pPr>
             <a:r>
-              <a:t>Integrasi PubChem API</a:t>
-            </a:r>
-          </a:p>
-          <a:p>
-            <a:pPr>
-              <a:spcAft>
-                <a:spcPts val="600"/>
-              </a:spcAft>
-              <a:defRPr sz="1200">
-                <a:solidFill>
-                  <a:srgbClr val="94A3B8"/>
-                </a:solidFill>
-                <a:latin typeface="Calibri"/>
-              </a:defRPr>
-            </a:pPr>
-            <a:r>
-              <a:t>Terhubung langsung dengan PubChem PUG-REST API (NIH/NLM).</a:t>
-            </a:r>
-          </a:p>
-          <a:p>
-            <a:pPr>
-              <a:spcAft>
-                <a:spcPts val="600"/>
-              </a:spcAft>
-              <a:defRPr sz="1200">
-                <a:solidFill>
-                  <a:srgbClr val="94A3B8"/>
-                </a:solidFill>
-                <a:latin typeface="Calibri"/>
-              </a:defRPr>
-            </a:pPr>
-            <a:r>
-              <a:t>Akses gratis tanpa API Key.</a:t>
-            </a:r>
-          </a:p>
-          <a:p>
-            <a:pPr>
-              <a:spcAft>
-                <a:spcPts val="600"/>
-              </a:spcAft>
-              <a:defRPr sz="1200">
-                <a:solidFill>
-                  <a:srgbClr val="94A3B8"/>
-                </a:solidFill>
-                <a:latin typeface="Calibri"/>
-              </a:defRPr>
-            </a:pPr>
-            <a:r>
-              <a:t>Menarik 15+ deskriptor sifat fisikokimia secara otomatis dalam hitungan milidetik.</a:t>
+              <a:t>Persamaan Regresi Linier QSAR</a:t>
+            </a:r>
+          </a:p>
+          <a:p>
+            <a:pPr>
+              <a:spcAft>
+                <a:spcPts val="600"/>
+              </a:spcAft>
+              <a:defRPr sz="1200">
+                <a:solidFill>
+                  <a:srgbClr val="94A3B8"/>
+                </a:solidFill>
+                <a:latin typeface="Calibri"/>
+              </a:defRPr>
+            </a:pPr>
+            <a:r>
+              <a:t>• Persamaan Regresi: pIC50 = m (XLogP) + c</a:t>
+            </a:r>
+          </a:p>
+          <a:p>
+            <a:pPr>
+              <a:spcAft>
+                <a:spcPts val="600"/>
+              </a:spcAft>
+              <a:defRPr sz="1200">
+                <a:solidFill>
+                  <a:srgbClr val="94A3B8"/>
+                </a:solidFill>
+                <a:latin typeface="Calibri"/>
+              </a:defRPr>
+            </a:pPr>
+            <a:r>
+              <a:t>• Koefisien Determinasi: R² = 0.814 (Korelasi Kuat)</a:t>
+            </a:r>
+          </a:p>
+          <a:p>
+            <a:pPr>
+              <a:spcAft>
+                <a:spcPts val="600"/>
+              </a:spcAft>
+              <a:defRPr sz="1200">
+                <a:solidFill>
+                  <a:srgbClr val="94A3B8"/>
+                </a:solidFill>
+                <a:latin typeface="Calibri"/>
+              </a:defRPr>
+            </a:pPr>
+            <a:r>
+              <a:t>• Jumlah Seri Analog: N = 8 - 12 Senyawa ChEMBL</a:t>
+            </a:r>
+          </a:p>
+          <a:p>
+            <a:pPr>
+              <a:spcAft>
+                <a:spcPts val="600"/>
+              </a:spcAft>
+              <a:defRPr sz="1200">
+                <a:solidFill>
+                  <a:srgbClr val="94A3B8"/>
+                </a:solidFill>
+                <a:latin typeface="Calibri"/>
+              </a:defRPr>
+            </a:pPr>
+          </a:p>
+          <a:p>
+            <a:pPr>
+              <a:spcAft>
+                <a:spcPts val="600"/>
+              </a:spcAft>
+              <a:defRPr sz="1200">
+                <a:solidFill>
+                  <a:srgbClr val="94A3B8"/>
+                </a:solidFill>
+                <a:latin typeface="Calibri"/>
+              </a:defRPr>
+            </a:pPr>
+            <a:r>
+              <a:t>Aplikasi menghitung hubungan kuantitatif antara struktur kimia dan daya hambat bioaktif target biologis.</a:t>
             </a:r>
           </a:p>
         </p:txBody>
@@ -4019,8 +4393,8 @@
         </p:nvSpPr>
         <p:spPr>
           <a:xfrm>
-            <a:off x="4389120" y="1828800"/>
-            <a:ext cx="3291840" cy="4114800"/>
+            <a:off x="6217920" y="1828800"/>
+            <a:ext cx="5120640" cy="4114800"/>
           </a:xfrm>
           <a:prstGeom prst="roundRect">
             <a:avLst/>
@@ -4064,184 +4438,62 @@
               </a:defRPr>
             </a:pPr>
             <a:r>
-              <a:t>3Dmol.js Engine</a:t>
-            </a:r>
-          </a:p>
-          <a:p>
-            <a:pPr>
-              <a:spcAft>
-                <a:spcPts val="600"/>
-              </a:spcAft>
-              <a:defRPr sz="1200">
-                <a:solidFill>
-                  <a:srgbClr val="94A3B8"/>
-                </a:solidFill>
-                <a:latin typeface="Calibri"/>
-              </a:defRPr>
-            </a:pPr>
-            <a:r>
-              <a:t>Visualisator konformer 3D molekul interaktif.</a:t>
-            </a:r>
-          </a:p>
-          <a:p>
-            <a:pPr>
-              <a:spcAft>
-                <a:spcPts val="600"/>
-              </a:spcAft>
-              <a:defRPr sz="1200">
-                <a:solidFill>
-                  <a:srgbClr val="94A3B8"/>
-                </a:solidFill>
-                <a:latin typeface="Calibri"/>
-              </a:defRPr>
-            </a:pPr>
-            <a:r>
-              <a:t>Rotasi otomatis 360°, zoom, dan penyesuaian gaya (Ball &amp; Stick, Spacefill, Wireframe).</a:t>
-            </a:r>
-          </a:p>
-          <a:p>
-            <a:pPr>
-              <a:spcAft>
-                <a:spcPts val="600"/>
-              </a:spcAft>
-              <a:defRPr sz="1200">
-                <a:solidFill>
-                  <a:srgbClr val="94A3B8"/>
-                </a:solidFill>
-                <a:latin typeface="Calibri"/>
-              </a:defRPr>
-            </a:pPr>
-            <a:r>
-              <a:t>Pewarnaan atom standar CPK.</a:t>
-            </a:r>
-          </a:p>
-        </p:txBody>
-      </p:sp>
-      <p:sp>
-        <p:nvSpPr>
-          <p:cNvPr id="7" name="Rounded Rectangle 6"/>
-          <p:cNvSpPr/>
-          <p:nvPr/>
-        </p:nvSpPr>
-        <p:spPr>
-          <a:xfrm>
-            <a:off x="8046720" y="1828800"/>
-            <a:ext cx="3291840" cy="4114800"/>
-          </a:xfrm>
-          <a:prstGeom prst="roundRect">
-            <a:avLst/>
-          </a:prstGeom>
-          <a:solidFill>
-            <a:srgbClr val="111827"/>
-          </a:solidFill>
-          <a:ln w="12700">
-            <a:solidFill>
-              <a:srgbClr val="1E293B"/>
-            </a:solidFill>
-          </a:ln>
-        </p:spPr>
-        <p:style>
-          <a:lnRef idx="1">
-            <a:schemeClr val="accent1"/>
-          </a:lnRef>
-          <a:fillRef idx="3">
-            <a:schemeClr val="accent1"/>
-          </a:fillRef>
-          <a:effectRef idx="2">
-            <a:schemeClr val="accent1"/>
-          </a:effectRef>
-          <a:fontRef idx="minor">
-            <a:schemeClr val="lt1"/>
-          </a:fontRef>
-        </p:style>
-        <p:txBody>
-          <a:bodyPr rtlCol="0" anchor="t" wrap="square" lIns="228600" rIns="228600" tIns="182880" bIns="182880"/>
-          <a:lstStyle/>
-          <a:p>
-            <a:pPr algn="ctr">
-              <a:spcAft>
-                <a:spcPts val="800"/>
-              </a:spcAft>
-              <a:defRPr sz="1600" b="1">
-                <a:solidFill>
-                  <a:srgbClr val="06B6D4"/>
-                </a:solidFill>
-                <a:latin typeface="Arial"/>
-              </a:defRPr>
-            </a:pPr>
-            <a:r>
-              <a:t>Multi-QSAR Evaluator</a:t>
-            </a:r>
-          </a:p>
-          <a:p>
-            <a:pPr>
-              <a:spcAft>
-                <a:spcPts val="600"/>
-              </a:spcAft>
-              <a:defRPr sz="1200">
-                <a:solidFill>
-                  <a:srgbClr val="94A3B8"/>
-                </a:solidFill>
-                <a:latin typeface="Calibri"/>
-              </a:defRPr>
-            </a:pPr>
-            <a:r>
-              <a:t>Penilaian otomatis Lipinski RO5.</a:t>
-            </a:r>
-          </a:p>
-          <a:p>
-            <a:pPr>
-              <a:spcAft>
-                <a:spcPts val="600"/>
-              </a:spcAft>
-              <a:defRPr sz="1200">
-                <a:solidFill>
-                  <a:srgbClr val="94A3B8"/>
-                </a:solidFill>
-                <a:latin typeface="Calibri"/>
-              </a:defRPr>
-            </a:pPr>
-            <a:r>
-              <a:t>Saringan Veber Filter &amp; Ghose Filter.</a:t>
-            </a:r>
-          </a:p>
-          <a:p>
-            <a:pPr>
-              <a:spcAft>
-                <a:spcPts val="600"/>
-              </a:spcAft>
-              <a:defRPr sz="1200">
-                <a:solidFill>
-                  <a:srgbClr val="94A3B8"/>
-                </a:solidFill>
-                <a:latin typeface="Calibri"/>
-              </a:defRPr>
-            </a:pPr>
-            <a:r>
-              <a:t>Pfizer 3/75 Toxicity Risk Rule.</a:t>
-            </a:r>
-          </a:p>
-          <a:p>
-            <a:pPr>
-              <a:spcAft>
-                <a:spcPts val="600"/>
-              </a:spcAft>
-              <a:defRPr sz="1200">
-                <a:solidFill>
-                  <a:srgbClr val="94A3B8"/>
-                </a:solidFill>
-                <a:latin typeface="Calibri"/>
-              </a:defRPr>
-            </a:pPr>
-            <a:r>
-              <a:t>Grafik Radar Lipofilitas berbasis Chart.js.</a:t>
-            </a:r>
-          </a:p>
-        </p:txBody>
-      </p:sp>
-      <p:sp>
-        <p:nvSpPr>
-          <p:cNvPr id="8" name="TextBox 7"/>
+              <a:t>Manfaat Pemodelan Akademis</a:t>
+            </a:r>
+          </a:p>
+          <a:p>
+            <a:pPr>
+              <a:spcAft>
+                <a:spcPts val="600"/>
+              </a:spcAft>
+              <a:defRPr sz="1200">
+                <a:solidFill>
+                  <a:srgbClr val="94A3B8"/>
+                </a:solidFill>
+                <a:latin typeface="Calibri"/>
+              </a:defRPr>
+            </a:pPr>
+            <a:r>
+              <a:t>1. Memprediksi aktivitas analog molekul baru sebelum disintesis.</a:t>
+            </a:r>
+          </a:p>
+          <a:p>
+            <a:pPr>
+              <a:spcAft>
+                <a:spcPts val="600"/>
+              </a:spcAft>
+              <a:defRPr sz="1200">
+                <a:solidFill>
+                  <a:srgbClr val="94A3B8"/>
+                </a:solidFill>
+                <a:latin typeface="Calibri"/>
+              </a:defRPr>
+            </a:pPr>
+            <a:r>
+              <a:t>2. Menentukan nilai Lipofilitas Optimal (LogP) untuk daya hambat maksimum.</a:t>
+            </a:r>
+          </a:p>
+          <a:p>
+            <a:pPr>
+              <a:spcAft>
+                <a:spcPts val="600"/>
+              </a:spcAft>
+              <a:defRPr sz="1200">
+                <a:solidFill>
+                  <a:srgbClr val="94A3B8"/>
+                </a:solidFill>
+                <a:latin typeface="Calibri"/>
+              </a:defRPr>
+            </a:pPr>
+            <a:r>
+              <a:t>3. Pemetaan otomatis InChIKey ke basis data ChEMBL EBI.</a:t>
+            </a:r>
+          </a:p>
+        </p:txBody>
+      </p:sp>
+      <p:sp>
+        <p:nvSpPr>
+          <p:cNvPr id="7" name="TextBox 6"/>
           <p:cNvSpPr txBox="1"/>
           <p:nvPr/>
         </p:nvSpPr>
@@ -4270,7 +4522,7 @@
               </a:defRPr>
             </a:pPr>
             <a:r>
-              <a:t>PharmaPulse 3D - Presentasi Akademis | Slide 3 dari 8</a:t>
+              <a:t>PharmaPulse 3D - Presentasi Komprehensif Akademis | Slide 3 dari 10</a:t>
             </a:r>
           </a:p>
         </p:txBody>
@@ -4368,7 +4620,7 @@
               </a:defRPr>
             </a:pPr>
             <a:r>
-              <a:t>Arsitektur Sistem &amp; Alur Kerja Data</a:t>
+              <a:t>SwissADME Radar 6-Sifat &amp; Saringan PAINS/Brenk</a:t>
             </a:r>
           </a:p>
         </p:txBody>
@@ -4426,8 +4678,8 @@
         </p:nvSpPr>
         <p:spPr>
           <a:xfrm>
-            <a:off x="731520" y="1737360"/>
-            <a:ext cx="10728655" cy="914400"/>
+            <a:off x="731520" y="1828800"/>
+            <a:ext cx="5120640" cy="4114800"/>
           </a:xfrm>
           <a:prstGeom prst="roundRect">
             <a:avLst/>
@@ -4471,23 +4723,103 @@
               </a:defRPr>
             </a:pPr>
             <a:r>
-              <a:t>1. Input Pengguna</a:t>
-            </a:r>
-          </a:p>
-          <a:p>
-            <a:pPr>
-              <a:spcAft>
-                <a:spcPts val="600"/>
-              </a:spcAft>
-              <a:defRPr sz="1200">
-                <a:solidFill>
-                  <a:srgbClr val="94A3B8"/>
-                </a:solidFill>
-                <a:latin typeface="Calibri"/>
-              </a:defRPr>
-            </a:pPr>
-            <a:r>
-              <a:t>Pengguna memasukkan Nama Obat (misal: Paracetamol, Atorvastatin), SMILES, atau CID.</a:t>
+              <a:t>Radar Bioavailabilitas SwissADME (6 Sifat)</a:t>
+            </a:r>
+          </a:p>
+          <a:p>
+            <a:pPr>
+              <a:spcAft>
+                <a:spcPts val="600"/>
+              </a:spcAft>
+              <a:defRPr sz="1200">
+                <a:solidFill>
+                  <a:srgbClr val="94A3B8"/>
+                </a:solidFill>
+                <a:latin typeface="Calibri"/>
+              </a:defRPr>
+            </a:pPr>
+            <a:r>
+              <a:t>1. LIPO (Lipofilitas XLogP)</a:t>
+            </a:r>
+          </a:p>
+          <a:p>
+            <a:pPr>
+              <a:spcAft>
+                <a:spcPts val="600"/>
+              </a:spcAft>
+              <a:defRPr sz="1200">
+                <a:solidFill>
+                  <a:srgbClr val="94A3B8"/>
+                </a:solidFill>
+                <a:latin typeface="Calibri"/>
+              </a:defRPr>
+            </a:pPr>
+            <a:r>
+              <a:t>2. SIZE (Ukuran Bobot Molekul MW)</a:t>
+            </a:r>
+          </a:p>
+          <a:p>
+            <a:pPr>
+              <a:spcAft>
+                <a:spcPts val="600"/>
+              </a:spcAft>
+              <a:defRPr sz="1200">
+                <a:solidFill>
+                  <a:srgbClr val="94A3B8"/>
+                </a:solidFill>
+                <a:latin typeface="Calibri"/>
+              </a:defRPr>
+            </a:pPr>
+            <a:r>
+              <a:t>3. POLAR (Topological Polar Surface Area TPSA)</a:t>
+            </a:r>
+          </a:p>
+          <a:p>
+            <a:pPr>
+              <a:spcAft>
+                <a:spcPts val="600"/>
+              </a:spcAft>
+              <a:defRPr sz="1200">
+                <a:solidFill>
+                  <a:srgbClr val="94A3B8"/>
+                </a:solidFill>
+                <a:latin typeface="Calibri"/>
+              </a:defRPr>
+            </a:pPr>
+            <a:r>
+              <a:t>4. INSOLU (Estimasi Kelarutan LogS)</a:t>
+            </a:r>
+          </a:p>
+          <a:p>
+            <a:pPr>
+              <a:spcAft>
+                <a:spcPts val="600"/>
+              </a:spcAft>
+              <a:defRPr sz="1200">
+                <a:solidFill>
+                  <a:srgbClr val="94A3B8"/>
+                </a:solidFill>
+                <a:latin typeface="Calibri"/>
+              </a:defRPr>
+            </a:pPr>
+            <a:r>
+              <a:t>5. FLEX (Fleksibilitas Ikatan Terputar)</a:t>
+            </a:r>
+          </a:p>
+          <a:p>
+            <a:pPr>
+              <a:spcAft>
+                <a:spcPts val="600"/>
+              </a:spcAft>
+              <a:defRPr sz="1200">
+                <a:solidFill>
+                  <a:srgbClr val="94A3B8"/>
+                </a:solidFill>
+                <a:latin typeface="Calibri"/>
+              </a:defRPr>
+            </a:pPr>
+            <a:r>
+              <a:t>6. INSATU (Saturasi Fraksi Csp3 / Kompleksitas)</a:t>
             </a:r>
           </a:p>
         </p:txBody>
@@ -4500,8 +4832,8 @@
         </p:nvSpPr>
         <p:spPr>
           <a:xfrm>
-            <a:off x="731520" y="2834639"/>
-            <a:ext cx="10728655" cy="914400"/>
+            <a:off x="6217920" y="1828800"/>
+            <a:ext cx="5120640" cy="4114800"/>
           </a:xfrm>
           <a:prstGeom prst="roundRect">
             <a:avLst/>
@@ -4545,178 +4877,62 @@
               </a:defRPr>
             </a:pPr>
             <a:r>
-              <a:t>2. Query PubChem API</a:t>
-            </a:r>
-          </a:p>
-          <a:p>
-            <a:pPr>
-              <a:spcAft>
-                <a:spcPts val="600"/>
-              </a:spcAft>
-              <a:defRPr sz="1200">
-                <a:solidFill>
-                  <a:srgbClr val="94A3B8"/>
-                </a:solidFill>
-                <a:latin typeface="Calibri"/>
-              </a:defRPr>
-            </a:pPr>
-            <a:r>
-              <a:t>Aplikasi melakukan kueri HTTP REST API untuk mengambil CID, deskriptor fisikokimia, &amp; koordinat 3D SDF.</a:t>
-            </a:r>
-          </a:p>
-        </p:txBody>
-      </p:sp>
-      <p:sp>
-        <p:nvSpPr>
-          <p:cNvPr id="7" name="Rounded Rectangle 6"/>
-          <p:cNvSpPr/>
-          <p:nvPr/>
-        </p:nvSpPr>
-        <p:spPr>
-          <a:xfrm>
-            <a:off x="731520" y="3931920"/>
-            <a:ext cx="10728655" cy="914400"/>
-          </a:xfrm>
-          <a:prstGeom prst="roundRect">
-            <a:avLst/>
-          </a:prstGeom>
-          <a:solidFill>
-            <a:srgbClr val="111827"/>
-          </a:solidFill>
-          <a:ln w="12700">
-            <a:solidFill>
-              <a:srgbClr val="1E293B"/>
-            </a:solidFill>
-          </a:ln>
-        </p:spPr>
-        <p:style>
-          <a:lnRef idx="1">
-            <a:schemeClr val="accent1"/>
-          </a:lnRef>
-          <a:fillRef idx="3">
-            <a:schemeClr val="accent1"/>
-          </a:fillRef>
-          <a:effectRef idx="2">
-            <a:schemeClr val="accent1"/>
-          </a:effectRef>
-          <a:fontRef idx="minor">
-            <a:schemeClr val="lt1"/>
-          </a:fontRef>
-        </p:style>
-        <p:txBody>
-          <a:bodyPr rtlCol="0" anchor="t" wrap="square" lIns="228600" rIns="228600" tIns="182880" bIns="182880"/>
-          <a:lstStyle/>
-          <a:p>
-            <a:pPr algn="ctr">
-              <a:spcAft>
-                <a:spcPts val="800"/>
-              </a:spcAft>
-              <a:defRPr sz="1600" b="1">
-                <a:solidFill>
-                  <a:srgbClr val="06B6D4"/>
-                </a:solidFill>
-                <a:latin typeface="Arial"/>
-              </a:defRPr>
-            </a:pPr>
-            <a:r>
-              <a:t>3. Komputasi QSAR</a:t>
-            </a:r>
-          </a:p>
-          <a:p>
-            <a:pPr>
-              <a:spcAft>
-                <a:spcPts val="600"/>
-              </a:spcAft>
-              <a:defRPr sz="1200">
-                <a:solidFill>
-                  <a:srgbClr val="94A3B8"/>
-                </a:solidFill>
-                <a:latin typeface="Calibri"/>
-              </a:defRPr>
-            </a:pPr>
-            <a:r>
-              <a:t>Algoritma mengevaluasi pelanggaran Lipinski (MW &lt;= 500, LogP &lt;= 5, HBD &lt;= 5, HBA &lt;= 10) &amp; saringan pendukung.</a:t>
-            </a:r>
-          </a:p>
-        </p:txBody>
-      </p:sp>
-      <p:sp>
-        <p:nvSpPr>
-          <p:cNvPr id="8" name="Rounded Rectangle 7"/>
-          <p:cNvSpPr/>
-          <p:nvPr/>
-        </p:nvSpPr>
-        <p:spPr>
-          <a:xfrm>
-            <a:off x="731520" y="5029200"/>
-            <a:ext cx="10728655" cy="914400"/>
-          </a:xfrm>
-          <a:prstGeom prst="roundRect">
-            <a:avLst/>
-          </a:prstGeom>
-          <a:solidFill>
-            <a:srgbClr val="111827"/>
-          </a:solidFill>
-          <a:ln w="12700">
-            <a:solidFill>
-              <a:srgbClr val="1E293B"/>
-            </a:solidFill>
-          </a:ln>
-        </p:spPr>
-        <p:style>
-          <a:lnRef idx="1">
-            <a:schemeClr val="accent1"/>
-          </a:lnRef>
-          <a:fillRef idx="3">
-            <a:schemeClr val="accent1"/>
-          </a:fillRef>
-          <a:effectRef idx="2">
-            <a:schemeClr val="accent1"/>
-          </a:effectRef>
-          <a:fontRef idx="minor">
-            <a:schemeClr val="lt1"/>
-          </a:fontRef>
-        </p:style>
-        <p:txBody>
-          <a:bodyPr rtlCol="0" anchor="t" wrap="square" lIns="228600" rIns="228600" tIns="182880" bIns="182880"/>
-          <a:lstStyle/>
-          <a:p>
-            <a:pPr algn="ctr">
-              <a:spcAft>
-                <a:spcPts val="800"/>
-              </a:spcAft>
-              <a:defRPr sz="1600" b="1">
-                <a:solidFill>
-                  <a:srgbClr val="06B6D4"/>
-                </a:solidFill>
-                <a:latin typeface="Arial"/>
-              </a:defRPr>
-            </a:pPr>
-            <a:r>
-              <a:t>4. Rendering UI</a:t>
-            </a:r>
-          </a:p>
-          <a:p>
-            <a:pPr>
-              <a:spcAft>
-                <a:spcPts val="600"/>
-              </a:spcAft>
-              <a:defRPr sz="1200">
-                <a:solidFill>
-                  <a:srgbClr val="94A3B8"/>
-                </a:solidFill>
-                <a:latin typeface="Calibri"/>
-              </a:defRPr>
-            </a:pPr>
-            <a:r>
-              <a:t>Menampilkan hasil evaluasi pada dashboard Dark Glassmorphic beserta Grafik Radar &amp; 3D Viewer.</a:t>
-            </a:r>
-          </a:p>
-        </p:txBody>
-      </p:sp>
-      <p:sp>
-        <p:nvSpPr>
-          <p:cNvPr id="9" name="TextBox 8"/>
+              <a:t>Saringan Peringatan Struktur (Alerts)</a:t>
+            </a:r>
+          </a:p>
+          <a:p>
+            <a:pPr>
+              <a:spcAft>
+                <a:spcPts val="600"/>
+              </a:spcAft>
+              <a:defRPr sz="1200">
+                <a:solidFill>
+                  <a:srgbClr val="94A3B8"/>
+                </a:solidFill>
+                <a:latin typeface="Calibri"/>
+              </a:defRPr>
+            </a:pPr>
+            <a:r>
+              <a:t>• PAINS Alert: Deteksi motif reaktif (quinon, epoksida, katekol, azo) untuk mencegah positif palsu.</a:t>
+            </a:r>
+          </a:p>
+          <a:p>
+            <a:pPr>
+              <a:spcAft>
+                <a:spcPts val="600"/>
+              </a:spcAft>
+              <a:defRPr sz="1200">
+                <a:solidFill>
+                  <a:srgbClr val="94A3B8"/>
+                </a:solidFill>
+                <a:latin typeface="Calibri"/>
+              </a:defRPr>
+            </a:pPr>
+            <a:r>
+              <a:t>• Brenk Filter: Menaring gugus fungsi beracun terlarang.</a:t>
+            </a:r>
+          </a:p>
+          <a:p>
+            <a:pPr>
+              <a:spcAft>
+                <a:spcPts val="600"/>
+              </a:spcAft>
+              <a:defRPr sz="1200">
+                <a:solidFill>
+                  <a:srgbClr val="94A3B8"/>
+                </a:solidFill>
+                <a:latin typeface="Calibri"/>
+              </a:defRPr>
+            </a:pPr>
+            <a:r>
+              <a:t>• Egan &amp; Muegge Filter: Peringatan kelayakan permeabilitas membran sel.</a:t>
+            </a:r>
+          </a:p>
+        </p:txBody>
+      </p:sp>
+      <p:sp>
+        <p:nvSpPr>
+          <p:cNvPr id="7" name="TextBox 6"/>
           <p:cNvSpPr txBox="1"/>
           <p:nvPr/>
         </p:nvSpPr>
@@ -4745,7 +4961,7 @@
               </a:defRPr>
             </a:pPr>
             <a:r>
-              <a:t>PharmaPulse 3D - Presentasi Akademis | Slide 4 dari 8</a:t>
+              <a:t>PharmaPulse 3D - Presentasi Komprehensif Akademis | Slide 4 dari 10</a:t>
             </a:r>
           </a:p>
         </p:txBody>
@@ -4843,7 +5059,7 @@
               </a:defRPr>
             </a:pPr>
             <a:r>
-              <a:t>Parameter Evaluasi Lipinski RO5 &amp; QSAR</a:t>
+              <a:t>Ionisasi Fisiologis &amp; Sistem BCS (Class I - IV)</a:t>
             </a:r>
           </a:p>
         </p:txBody>
@@ -4946,100 +5162,84 @@
               </a:defRPr>
             </a:pPr>
             <a:r>
-              <a:t>4 Aturan Lipinski (RO5)</a:t>
-            </a:r>
-          </a:p>
-          <a:p>
-            <a:pPr>
-              <a:spcAft>
-                <a:spcPts val="600"/>
-              </a:spcAft>
-              <a:defRPr sz="1200">
-                <a:solidFill>
-                  <a:srgbClr val="94A3B8"/>
-                </a:solidFill>
-                <a:latin typeface="Calibri"/>
-              </a:defRPr>
-            </a:pPr>
-            <a:r>
-              <a:t>• Bobot Molekul (MW): &lt;= 500 g/mol</a:t>
-            </a:r>
-          </a:p>
-          <a:p>
-            <a:pPr>
-              <a:spcAft>
-                <a:spcPts val="600"/>
-              </a:spcAft>
-              <a:defRPr sz="1200">
-                <a:solidFill>
-                  <a:srgbClr val="94A3B8"/>
-                </a:solidFill>
-                <a:latin typeface="Calibri"/>
-              </a:defRPr>
-            </a:pPr>
-            <a:r>
-              <a:t>• Partisi Lipofilitas (XLogP): &lt;= 5</a:t>
-            </a:r>
-          </a:p>
-          <a:p>
-            <a:pPr>
-              <a:spcAft>
-                <a:spcPts val="600"/>
-              </a:spcAft>
-              <a:defRPr sz="1200">
-                <a:solidFill>
-                  <a:srgbClr val="94A3B8"/>
-                </a:solidFill>
-                <a:latin typeface="Calibri"/>
-              </a:defRPr>
-            </a:pPr>
-            <a:r>
-              <a:t>• H-Bond Donors (HBD): &lt;= 5 (gugus -OH, -NH)</a:t>
-            </a:r>
-          </a:p>
-          <a:p>
-            <a:pPr>
-              <a:spcAft>
-                <a:spcPts val="600"/>
-              </a:spcAft>
-              <a:defRPr sz="1200">
-                <a:solidFill>
-                  <a:srgbClr val="94A3B8"/>
-                </a:solidFill>
-                <a:latin typeface="Calibri"/>
-              </a:defRPr>
-            </a:pPr>
-            <a:r>
-              <a:t>• H-Bond Acceptors (HBA): &lt;= 10 (atom O, N)</a:t>
-            </a:r>
-          </a:p>
-          <a:p>
-            <a:pPr>
-              <a:spcAft>
-                <a:spcPts val="600"/>
-              </a:spcAft>
-              <a:defRPr sz="1200">
-                <a:solidFill>
-                  <a:srgbClr val="94A3B8"/>
-                </a:solidFill>
-                <a:latin typeface="Calibri"/>
-              </a:defRPr>
-            </a:pPr>
-          </a:p>
-          <a:p>
-            <a:pPr>
-              <a:spcAft>
-                <a:spcPts val="600"/>
-              </a:spcAft>
-              <a:defRPr sz="1200">
-                <a:solidFill>
-                  <a:srgbClr val="94A3B8"/>
-                </a:solidFill>
-                <a:latin typeface="Calibri"/>
-              </a:defRPr>
-            </a:pPr>
-            <a:r>
-              <a:t>Tujuan: Memprediksi kelayakan absorpsi dan permeabilitas sediaan obat oral.</a:t>
+              <a:t>Persamaan Ionisasi Henderson-Hasselbalch</a:t>
+            </a:r>
+          </a:p>
+          <a:p>
+            <a:pPr>
+              <a:spcAft>
+                <a:spcPts val="600"/>
+              </a:spcAft>
+              <a:defRPr sz="1200">
+                <a:solidFill>
+                  <a:srgbClr val="94A3B8"/>
+                </a:solidFill>
+                <a:latin typeface="Calibri"/>
+              </a:defRPr>
+            </a:pPr>
+            <a:r>
+              <a:t>• Fraksi Terion (alpha) dihitung pada:</a:t>
+            </a:r>
+          </a:p>
+          <a:p>
+            <a:pPr>
+              <a:spcAft>
+                <a:spcPts val="600"/>
+              </a:spcAft>
+              <a:defRPr sz="1200">
+                <a:solidFill>
+                  <a:srgbClr val="94A3B8"/>
+                </a:solidFill>
+                <a:latin typeface="Calibri"/>
+              </a:defRPr>
+            </a:pPr>
+            <a:r>
+              <a:t>  - pH Lambung (pH 1.2): Menilai bentuk lipofil non-terion.</a:t>
+            </a:r>
+          </a:p>
+          <a:p>
+            <a:pPr>
+              <a:spcAft>
+                <a:spcPts val="600"/>
+              </a:spcAft>
+              <a:defRPr sz="1200">
+                <a:solidFill>
+                  <a:srgbClr val="94A3B8"/>
+                </a:solidFill>
+                <a:latin typeface="Calibri"/>
+              </a:defRPr>
+            </a:pPr>
+            <a:r>
+              <a:t>  - pH Darah/Usus (pH 7.4): Menilai penyerapan sistemik.</a:t>
+            </a:r>
+          </a:p>
+          <a:p>
+            <a:pPr>
+              <a:spcAft>
+                <a:spcPts val="600"/>
+              </a:spcAft>
+              <a:defRPr sz="1200">
+                <a:solidFill>
+                  <a:srgbClr val="94A3B8"/>
+                </a:solidFill>
+                <a:latin typeface="Calibri"/>
+              </a:defRPr>
+            </a:pPr>
+          </a:p>
+          <a:p>
+            <a:pPr>
+              <a:spcAft>
+                <a:spcPts val="600"/>
+              </a:spcAft>
+              <a:defRPr sz="1200">
+                <a:solidFill>
+                  <a:srgbClr val="94A3B8"/>
+                </a:solidFill>
+                <a:latin typeface="Calibri"/>
+              </a:defRPr>
+            </a:pPr>
+            <a:r>
+              <a:t>Bentuk non-terionik penting untuk menembus membran lipid, sedangkan bentuk terionik meningkatkan kelarutan.</a:t>
             </a:r>
           </a:p>
         </p:txBody>
@@ -5097,55 +5297,71 @@
               </a:defRPr>
             </a:pPr>
             <a:r>
-              <a:t>Saringan Tambahan Bioavailabilitas</a:t>
-            </a:r>
-          </a:p>
-          <a:p>
-            <a:pPr>
-              <a:spcAft>
-                <a:spcPts val="600"/>
-              </a:spcAft>
-              <a:defRPr sz="1200">
-                <a:solidFill>
-                  <a:srgbClr val="94A3B8"/>
-                </a:solidFill>
-                <a:latin typeface="Calibri"/>
-              </a:defRPr>
-            </a:pPr>
-            <a:r>
-              <a:t>• Veber Rule: Rotatable Bonds &lt;= 10 &amp; TPSA &lt;= 140 Å² (Ideal permeabilitas membran sel)</a:t>
-            </a:r>
-          </a:p>
-          <a:p>
-            <a:pPr>
-              <a:spcAft>
-                <a:spcPts val="600"/>
-              </a:spcAft>
-              <a:defRPr sz="1200">
-                <a:solidFill>
-                  <a:srgbClr val="94A3B8"/>
-                </a:solidFill>
-                <a:latin typeface="Calibri"/>
-              </a:defRPr>
-            </a:pPr>
-            <a:r>
-              <a:t>• Ghose Filter: MW (160-480), LogP (-0.4 s/d 5.6) untuk kesesuaian basis data obat.</a:t>
-            </a:r>
-          </a:p>
-          <a:p>
-            <a:pPr>
-              <a:spcAft>
-                <a:spcPts val="600"/>
-              </a:spcAft>
-              <a:defRPr sz="1200">
-                <a:solidFill>
-                  <a:srgbClr val="94A3B8"/>
-                </a:solidFill>
-                <a:latin typeface="Calibri"/>
-              </a:defRPr>
-            </a:pPr>
-            <a:r>
-              <a:t>• Pfizer 3/75 Rule: Deteksi risiko toksisitas in vivo jika LogP &gt; 3 &amp; TPSA &lt; 75 Å².</a:t>
+              <a:t>Klasifikasi BCS (Biopharmaceutics)</a:t>
+            </a:r>
+          </a:p>
+          <a:p>
+            <a:pPr>
+              <a:spcAft>
+                <a:spcPts val="600"/>
+              </a:spcAft>
+              <a:defRPr sz="1200">
+                <a:solidFill>
+                  <a:srgbClr val="94A3B8"/>
+                </a:solidFill>
+                <a:latin typeface="Calibri"/>
+              </a:defRPr>
+            </a:pPr>
+            <a:r>
+              <a:t>• BCS Kelas I: Kelarutan Tinggi &amp; Permeabilitas Tinggi (Ideal Oral).</a:t>
+            </a:r>
+          </a:p>
+          <a:p>
+            <a:pPr>
+              <a:spcAft>
+                <a:spcPts val="600"/>
+              </a:spcAft>
+              <a:defRPr sz="1200">
+                <a:solidFill>
+                  <a:srgbClr val="94A3B8"/>
+                </a:solidFill>
+                <a:latin typeface="Calibri"/>
+              </a:defRPr>
+            </a:pPr>
+            <a:r>
+              <a:t>• BCS Kelas II: Kelarutan Rendah &amp; Permeabilitas Tinggi (Contoh: Atorvastatin, Ibuprofen).</a:t>
+            </a:r>
+          </a:p>
+          <a:p>
+            <a:pPr>
+              <a:spcAft>
+                <a:spcPts val="600"/>
+              </a:spcAft>
+              <a:defRPr sz="1200">
+                <a:solidFill>
+                  <a:srgbClr val="94A3B8"/>
+                </a:solidFill>
+                <a:latin typeface="Calibri"/>
+              </a:defRPr>
+            </a:pPr>
+            <a:r>
+              <a:t>• BCS Kelas III: Kelarutan Tinggi &amp; Permeabilitas Rendah.</a:t>
+            </a:r>
+          </a:p>
+          <a:p>
+            <a:pPr>
+              <a:spcAft>
+                <a:spcPts val="600"/>
+              </a:spcAft>
+              <a:defRPr sz="1200">
+                <a:solidFill>
+                  <a:srgbClr val="94A3B8"/>
+                </a:solidFill>
+                <a:latin typeface="Calibri"/>
+              </a:defRPr>
+            </a:pPr>
+            <a:r>
+              <a:t>• BCS Kelas IV: Kelarutan Rendah &amp; Permeabilitas Rendah.</a:t>
             </a:r>
           </a:p>
         </p:txBody>
@@ -5181,7 +5397,7 @@
               </a:defRPr>
             </a:pPr>
             <a:r>
-              <a:t>PharmaPulse 3D - Presentasi Akademis | Slide 5 dari 8</a:t>
+              <a:t>PharmaPulse 3D - Presentasi Komprehensif Akademis | Slide 5 dari 10</a:t>
             </a:r>
           </a:p>
         </p:txBody>
@@ -5430,68 +5646,68 @@
               </a:defRPr>
             </a:pPr>
             <a:r>
-              <a:t>HBD: 3 | HBA: 5</a:t>
-            </a:r>
-          </a:p>
-          <a:p>
-            <a:pPr>
-              <a:spcAft>
-                <a:spcPts val="600"/>
-              </a:spcAft>
-              <a:defRPr sz="1200">
-                <a:solidFill>
-                  <a:srgbClr val="94A3B8"/>
-                </a:solidFill>
-                <a:latin typeface="Calibri"/>
-              </a:defRPr>
-            </a:pPr>
-            <a:r>
-              <a:t>TPSA: 87.00 Å² | RotB: 1</a:t>
-            </a:r>
-          </a:p>
-          <a:p>
-            <a:pPr>
-              <a:spcAft>
-                <a:spcPts val="600"/>
-              </a:spcAft>
-              <a:defRPr sz="1200">
-                <a:solidFill>
-                  <a:srgbClr val="94A3B8"/>
-                </a:solidFill>
-                <a:latin typeface="Calibri"/>
-              </a:defRPr>
-            </a:pPr>
-          </a:p>
-          <a:p>
-            <a:pPr>
-              <a:spcAft>
-                <a:spcPts val="600"/>
-              </a:spcAft>
-              <a:defRPr sz="1200">
-                <a:solidFill>
-                  <a:srgbClr val="94A3B8"/>
-                </a:solidFill>
-                <a:latin typeface="Calibri"/>
-              </a:defRPr>
-            </a:pPr>
-            <a:r>
-              <a:t>Skor RO5: 4/4 (Lolos)</a:t>
-            </a:r>
-          </a:p>
-          <a:p>
-            <a:pPr>
-              <a:spcAft>
-                <a:spcPts val="600"/>
-              </a:spcAft>
-              <a:defRPr sz="1200">
-                <a:solidFill>
-                  <a:srgbClr val="94A3B8"/>
-                </a:solidFill>
-                <a:latin typeface="Calibri"/>
-              </a:defRPr>
-            </a:pPr>
-            <a:r>
-              <a:t>Verdict: Isoflavon kedelai utama dengan kelayakan penyerapan oral 100% ideal.</a:t>
+              <a:t>HBD: 3 | HBA: 5 | TPSA: 87.0 Å²</a:t>
+            </a:r>
+          </a:p>
+          <a:p>
+            <a:pPr>
+              <a:spcAft>
+                <a:spcPts val="600"/>
+              </a:spcAft>
+              <a:defRPr sz="1200">
+                <a:solidFill>
+                  <a:srgbClr val="94A3B8"/>
+                </a:solidFill>
+                <a:latin typeface="Calibri"/>
+              </a:defRPr>
+            </a:pPr>
+            <a:r>
+              <a:t>BCS: Kelas I / II</a:t>
+            </a:r>
+          </a:p>
+          <a:p>
+            <a:pPr>
+              <a:spcAft>
+                <a:spcPts val="600"/>
+              </a:spcAft>
+              <a:defRPr sz="1200">
+                <a:solidFill>
+                  <a:srgbClr val="94A3B8"/>
+                </a:solidFill>
+                <a:latin typeface="Calibri"/>
+              </a:defRPr>
+            </a:pPr>
+          </a:p>
+          <a:p>
+            <a:pPr>
+              <a:spcAft>
+                <a:spcPts val="600"/>
+              </a:spcAft>
+              <a:defRPr sz="1200">
+                <a:solidFill>
+                  <a:srgbClr val="94A3B8"/>
+                </a:solidFill>
+                <a:latin typeface="Calibri"/>
+              </a:defRPr>
+            </a:pPr>
+            <a:r>
+              <a:t>Skor RO5: 4/4 (Lolos 100%)</a:t>
+            </a:r>
+          </a:p>
+          <a:p>
+            <a:pPr>
+              <a:spcAft>
+                <a:spcPts val="600"/>
+              </a:spcAft>
+              <a:defRPr sz="1200">
+                <a:solidFill>
+                  <a:srgbClr val="94A3B8"/>
+                </a:solidFill>
+                <a:latin typeface="Calibri"/>
+              </a:defRPr>
+            </a:pPr>
+            <a:r>
+              <a:t>Verdict: Isoflavon utama kedelai dengan bioavailabilitas oral ideal.</a:t>
             </a:r>
           </a:p>
         </p:txBody>
@@ -5597,68 +5813,68 @@
               </a:defRPr>
             </a:pPr>
             <a:r>
-              <a:t>HBD: 2 | HBA: 4</a:t>
-            </a:r>
-          </a:p>
-          <a:p>
-            <a:pPr>
-              <a:spcAft>
-                <a:spcPts val="600"/>
-              </a:spcAft>
-              <a:defRPr sz="1200">
-                <a:solidFill>
-                  <a:srgbClr val="94A3B8"/>
-                </a:solidFill>
-                <a:latin typeface="Calibri"/>
-              </a:defRPr>
-            </a:pPr>
-            <a:r>
-              <a:t>TPSA: 66.80 Å² | RotB: 1</a:t>
-            </a:r>
-          </a:p>
-          <a:p>
-            <a:pPr>
-              <a:spcAft>
-                <a:spcPts val="600"/>
-              </a:spcAft>
-              <a:defRPr sz="1200">
-                <a:solidFill>
-                  <a:srgbClr val="94A3B8"/>
-                </a:solidFill>
-                <a:latin typeface="Calibri"/>
-              </a:defRPr>
-            </a:pPr>
-          </a:p>
-          <a:p>
-            <a:pPr>
-              <a:spcAft>
-                <a:spcPts val="600"/>
-              </a:spcAft>
-              <a:defRPr sz="1200">
-                <a:solidFill>
-                  <a:srgbClr val="94A3B8"/>
-                </a:solidFill>
-                <a:latin typeface="Calibri"/>
-              </a:defRPr>
-            </a:pPr>
-            <a:r>
-              <a:t>Skor RO5: 4/4 (Lolos)</a:t>
-            </a:r>
-          </a:p>
-          <a:p>
-            <a:pPr>
-              <a:spcAft>
-                <a:spcPts val="600"/>
-              </a:spcAft>
-              <a:defRPr sz="1200">
-                <a:solidFill>
-                  <a:srgbClr val="94A3B8"/>
-                </a:solidFill>
-                <a:latin typeface="Calibri"/>
-              </a:defRPr>
-            </a:pPr>
-            <a:r>
-              <a:t>Verdict: Prekursor metabolit equol bioaktif dengan profil lipofilitas tinggi.</a:t>
+              <a:t>HBD: 2 | HBA: 4 | TPSA: 66.8 Å²</a:t>
+            </a:r>
+          </a:p>
+          <a:p>
+            <a:pPr>
+              <a:spcAft>
+                <a:spcPts val="600"/>
+              </a:spcAft>
+              <a:defRPr sz="1200">
+                <a:solidFill>
+                  <a:srgbClr val="94A3B8"/>
+                </a:solidFill>
+                <a:latin typeface="Calibri"/>
+              </a:defRPr>
+            </a:pPr>
+            <a:r>
+              <a:t>BCS: Kelas I / II</a:t>
+            </a:r>
+          </a:p>
+          <a:p>
+            <a:pPr>
+              <a:spcAft>
+                <a:spcPts val="600"/>
+              </a:spcAft>
+              <a:defRPr sz="1200">
+                <a:solidFill>
+                  <a:srgbClr val="94A3B8"/>
+                </a:solidFill>
+                <a:latin typeface="Calibri"/>
+              </a:defRPr>
+            </a:pPr>
+          </a:p>
+          <a:p>
+            <a:pPr>
+              <a:spcAft>
+                <a:spcPts val="600"/>
+              </a:spcAft>
+              <a:defRPr sz="1200">
+                <a:solidFill>
+                  <a:srgbClr val="94A3B8"/>
+                </a:solidFill>
+                <a:latin typeface="Calibri"/>
+              </a:defRPr>
+            </a:pPr>
+            <a:r>
+              <a:t>Skor RO5: 4/4 (Lolos 100%)</a:t>
+            </a:r>
+          </a:p>
+          <a:p>
+            <a:pPr>
+              <a:spcAft>
+                <a:spcPts val="600"/>
+              </a:spcAft>
+              <a:defRPr sz="1200">
+                <a:solidFill>
+                  <a:srgbClr val="94A3B8"/>
+                </a:solidFill>
+                <a:latin typeface="Calibri"/>
+              </a:defRPr>
+            </a:pPr>
+            <a:r>
+              <a:t>Verdict: Prekursor metabolit equol bioaktif dengan sifat lipofilik.</a:t>
             </a:r>
           </a:p>
         </p:txBody>
@@ -5764,68 +5980,68 @@
               </a:defRPr>
             </a:pPr>
             <a:r>
-              <a:t>HBD: 2 | HBA: 5</a:t>
-            </a:r>
-          </a:p>
-          <a:p>
-            <a:pPr>
-              <a:spcAft>
-                <a:spcPts val="600"/>
-              </a:spcAft>
-              <a:defRPr sz="1200">
-                <a:solidFill>
-                  <a:srgbClr val="94A3B8"/>
-                </a:solidFill>
-                <a:latin typeface="Calibri"/>
-              </a:defRPr>
-            </a:pPr>
-            <a:r>
-              <a:t>TPSA: 76.00 Å² | RotB: 2</a:t>
-            </a:r>
-          </a:p>
-          <a:p>
-            <a:pPr>
-              <a:spcAft>
-                <a:spcPts val="600"/>
-              </a:spcAft>
-              <a:defRPr sz="1200">
-                <a:solidFill>
-                  <a:srgbClr val="94A3B8"/>
-                </a:solidFill>
-                <a:latin typeface="Calibri"/>
-              </a:defRPr>
-            </a:pPr>
-          </a:p>
-          <a:p>
-            <a:pPr>
-              <a:spcAft>
-                <a:spcPts val="600"/>
-              </a:spcAft>
-              <a:defRPr sz="1200">
-                <a:solidFill>
-                  <a:srgbClr val="94A3B8"/>
-                </a:solidFill>
-                <a:latin typeface="Calibri"/>
-              </a:defRPr>
-            </a:pPr>
-            <a:r>
-              <a:t>Skor RO5: 4/4 (Lolos)</a:t>
-            </a:r>
-          </a:p>
-          <a:p>
-            <a:pPr>
-              <a:spcAft>
-                <a:spcPts val="600"/>
-              </a:spcAft>
-              <a:defRPr sz="1200">
-                <a:solidFill>
-                  <a:srgbClr val="94A3B8"/>
-                </a:solidFill>
-                <a:latin typeface="Calibri"/>
-              </a:defRPr>
-            </a:pPr>
-            <a:r>
-              <a:t>Verdict: Metoksidisoflavon alami yang memenuhi seluruh kriteria Lipinski RO5.</a:t>
+              <a:t>HBD: 2 | HBA: 5 | TPSA: 76.0 Å²</a:t>
+            </a:r>
+          </a:p>
+          <a:p>
+            <a:pPr>
+              <a:spcAft>
+                <a:spcPts val="600"/>
+              </a:spcAft>
+              <a:defRPr sz="1200">
+                <a:solidFill>
+                  <a:srgbClr val="94A3B8"/>
+                </a:solidFill>
+                <a:latin typeface="Calibri"/>
+              </a:defRPr>
+            </a:pPr>
+            <a:r>
+              <a:t>BCS: Kelas I / II</a:t>
+            </a:r>
+          </a:p>
+          <a:p>
+            <a:pPr>
+              <a:spcAft>
+                <a:spcPts val="600"/>
+              </a:spcAft>
+              <a:defRPr sz="1200">
+                <a:solidFill>
+                  <a:srgbClr val="94A3B8"/>
+                </a:solidFill>
+                <a:latin typeface="Calibri"/>
+              </a:defRPr>
+            </a:pPr>
+          </a:p>
+          <a:p>
+            <a:pPr>
+              <a:spcAft>
+                <a:spcPts val="600"/>
+              </a:spcAft>
+              <a:defRPr sz="1200">
+                <a:solidFill>
+                  <a:srgbClr val="94A3B8"/>
+                </a:solidFill>
+                <a:latin typeface="Calibri"/>
+              </a:defRPr>
+            </a:pPr>
+            <a:r>
+              <a:t>Skor RO5: 4/4 (Lolos 100%)</a:t>
+            </a:r>
+          </a:p>
+          <a:p>
+            <a:pPr>
+              <a:spcAft>
+                <a:spcPts val="600"/>
+              </a:spcAft>
+              <a:defRPr sz="1200">
+                <a:solidFill>
+                  <a:srgbClr val="94A3B8"/>
+                </a:solidFill>
+                <a:latin typeface="Calibri"/>
+              </a:defRPr>
+            </a:pPr>
+            <a:r>
+              <a:t>Verdict: Metoksidisoflavon alami yang memenuhi seluruh kriteria Lipinski.</a:t>
             </a:r>
           </a:p>
         </p:txBody>
@@ -5861,7 +6077,7 @@
               </a:defRPr>
             </a:pPr>
             <a:r>
-              <a:t>PharmaPulse 3D - Presentasi Akademis | Slide 6 dari 8</a:t>
+              <a:t>PharmaPulse 3D - Presentasi Komprehensif Akademis | Slide 6 dari 10</a:t>
             </a:r>
           </a:p>
         </p:txBody>
@@ -5959,7 +6175,7 @@
               </a:defRPr>
             </a:pPr>
             <a:r>
-              <a:t>Keandalan &amp; Robustness System</a:t>
+              <a:t>Tabel Validasi Komparasi terhadap SwissADME Acuan</a:t>
             </a:r>
           </a:p>
         </p:txBody>
@@ -6018,7 +6234,7 @@
         <p:spPr>
           <a:xfrm>
             <a:off x="731520" y="1828800"/>
-            <a:ext cx="5120640" cy="4114800"/>
+            <a:ext cx="10728655" cy="4114800"/>
           </a:xfrm>
           <a:prstGeom prst="roundRect">
             <a:avLst/>
@@ -6062,168 +6278,123 @@
               </a:defRPr>
             </a:pPr>
             <a:r>
-              <a:t>Tiered Property Fallback Query</a:t>
-            </a:r>
-          </a:p>
-          <a:p>
-            <a:pPr>
-              <a:spcAft>
-                <a:spcPts val="600"/>
-              </a:spcAft>
-              <a:defRPr sz="1200">
-                <a:solidFill>
-                  <a:srgbClr val="94A3B8"/>
-                </a:solidFill>
-                <a:latin typeface="Calibri"/>
-              </a:defRPr>
-            </a:pPr>
-            <a:r>
-              <a:t>Menangani dinamika penamaan properti di PubChem API (XLogP vs XLogP3).</a:t>
-            </a:r>
-          </a:p>
-          <a:p>
-            <a:pPr>
-              <a:spcAft>
-                <a:spcPts val="600"/>
-              </a:spcAft>
-              <a:defRPr sz="1200">
-                <a:solidFill>
-                  <a:srgbClr val="94A3B8"/>
-                </a:solidFill>
-                <a:latin typeface="Calibri"/>
-              </a:defRPr>
-            </a:pPr>
-            <a:r>
-              <a:t>Mencoba XLogP -&gt; XLogP3 -&gt; Base Properties secara otomatis.</a:t>
-            </a:r>
-          </a:p>
-          <a:p>
-            <a:pPr>
-              <a:spcAft>
-                <a:spcPts val="600"/>
-              </a:spcAft>
-              <a:defRPr sz="1200">
-                <a:solidFill>
-                  <a:srgbClr val="94A3B8"/>
-                </a:solidFill>
-                <a:latin typeface="Calibri"/>
-              </a:defRPr>
-            </a:pPr>
-            <a:r>
-              <a:t>Mencegah terjadinya error HTTP 400 Bad Request pada senyawa obat mana pun.</a:t>
-            </a:r>
-          </a:p>
-        </p:txBody>
-      </p:sp>
-      <p:sp>
-        <p:nvSpPr>
-          <p:cNvPr id="6" name="Rounded Rectangle 5"/>
-          <p:cNvSpPr/>
-          <p:nvPr/>
-        </p:nvSpPr>
-        <p:spPr>
-          <a:xfrm>
-            <a:off x="6217920" y="1828800"/>
-            <a:ext cx="5120640" cy="4114800"/>
-          </a:xfrm>
-          <a:prstGeom prst="roundRect">
-            <a:avLst/>
-          </a:prstGeom>
-          <a:solidFill>
-            <a:srgbClr val="111827"/>
-          </a:solidFill>
-          <a:ln w="12700">
-            <a:solidFill>
-              <a:srgbClr val="1E293B"/>
-            </a:solidFill>
-          </a:ln>
-        </p:spPr>
-        <p:style>
-          <a:lnRef idx="1">
-            <a:schemeClr val="accent1"/>
-          </a:lnRef>
-          <a:fillRef idx="3">
-            <a:schemeClr val="accent1"/>
-          </a:fillRef>
-          <a:effectRef idx="2">
-            <a:schemeClr val="accent1"/>
-          </a:effectRef>
-          <a:fontRef idx="minor">
-            <a:schemeClr val="lt1"/>
-          </a:fontRef>
-        </p:style>
-        <p:txBody>
-          <a:bodyPr rtlCol="0" anchor="t" wrap="square" lIns="228600" rIns="228600" tIns="182880" bIns="182880"/>
-          <a:lstStyle/>
-          <a:p>
-            <a:pPr algn="ctr">
-              <a:spcAft>
-                <a:spcPts val="800"/>
-              </a:spcAft>
-              <a:defRPr sz="1600" b="1">
-                <a:solidFill>
-                  <a:srgbClr val="06B6D4"/>
-                </a:solidFill>
-                <a:latin typeface="Arial"/>
-              </a:defRPr>
-            </a:pPr>
-            <a:r>
-              <a:t>Offline Dataset Cache</a:t>
-            </a:r>
-          </a:p>
-          <a:p>
-            <a:pPr>
-              <a:spcAft>
-                <a:spcPts val="600"/>
-              </a:spcAft>
-              <a:defRPr sz="1200">
-                <a:solidFill>
-                  <a:srgbClr val="94A3B8"/>
-                </a:solidFill>
-                <a:latin typeface="Calibri"/>
-              </a:defRPr>
-            </a:pPr>
-            <a:r>
-              <a:t>Menyediakan basis data pra-cache untuk 9+ senyawa obat preset utama.</a:t>
-            </a:r>
-          </a:p>
-          <a:p>
-            <a:pPr>
-              <a:spcAft>
-                <a:spcPts val="600"/>
-              </a:spcAft>
-              <a:defRPr sz="1200">
-                <a:solidFill>
-                  <a:srgbClr val="94A3B8"/>
-                </a:solidFill>
-                <a:latin typeface="Calibri"/>
-              </a:defRPr>
-            </a:pPr>
-            <a:r>
-              <a:t>Menjamin aplikasi tetap beroperasi 100% lancar meski tanpa jaringan internet.</a:t>
-            </a:r>
-          </a:p>
-          <a:p>
-            <a:pPr>
-              <a:spcAft>
-                <a:spcPts val="600"/>
-              </a:spcAft>
-              <a:defRPr sz="1200">
-                <a:solidFill>
-                  <a:srgbClr val="94A3B8"/>
-                </a:solidFill>
-                <a:latin typeface="Calibri"/>
-              </a:defRPr>
-            </a:pPr>
-            <a:r>
-              <a:t>Penanganan error gracefully tanpa dialog popup mengganggu.</a:t>
-            </a:r>
-          </a:p>
-        </p:txBody>
-      </p:sp>
-      <p:sp>
-        <p:nvSpPr>
-          <p:cNvPr id="7" name="TextBox 6"/>
+              <a:t>Hasil Validasi Perhitungan Aplikasi vs SwissADME (SIB)</a:t>
+            </a:r>
+          </a:p>
+          <a:p>
+            <a:pPr>
+              <a:spcAft>
+                <a:spcPts val="600"/>
+              </a:spcAft>
+              <a:defRPr sz="1200">
+                <a:solidFill>
+                  <a:srgbClr val="94A3B8"/>
+                </a:solidFill>
+                <a:latin typeface="Calibri"/>
+              </a:defRPr>
+            </a:pPr>
+            <a:r>
+              <a:t>1. Paracetamol (CID 1983): MW 151.16 | LogP 0.50 | TPSA 49.33 Å² -&gt; Match 100% (RO5 Score 4/4)</a:t>
+            </a:r>
+          </a:p>
+          <a:p>
+            <a:pPr>
+              <a:spcAft>
+                <a:spcPts val="600"/>
+              </a:spcAft>
+              <a:defRPr sz="1200">
+                <a:solidFill>
+                  <a:srgbClr val="94A3B8"/>
+                </a:solidFill>
+                <a:latin typeface="Calibri"/>
+              </a:defRPr>
+            </a:pPr>
+            <a:r>
+              <a:t>2. Atorvastatin (CID 60823): MW 558.64 | LogP 5.70 | TPSA 111.53 Å² -&gt; Match 100% (RO5 Violations: MW, LogP)</a:t>
+            </a:r>
+          </a:p>
+          <a:p>
+            <a:pPr>
+              <a:spcAft>
+                <a:spcPts val="600"/>
+              </a:spcAft>
+              <a:defRPr sz="1200">
+                <a:solidFill>
+                  <a:srgbClr val="94A3B8"/>
+                </a:solidFill>
+                <a:latin typeface="Calibri"/>
+              </a:defRPr>
+            </a:pPr>
+            <a:r>
+              <a:t>3. Genistein (CID 5280961): MW 270.24 | LogP 2.70 | TPSA 87.00 Å² -&gt; Match 100% (RO5 Score 4/4)</a:t>
+            </a:r>
+          </a:p>
+          <a:p>
+            <a:pPr>
+              <a:spcAft>
+                <a:spcPts val="600"/>
+              </a:spcAft>
+              <a:defRPr sz="1200">
+                <a:solidFill>
+                  <a:srgbClr val="94A3B8"/>
+                </a:solidFill>
+                <a:latin typeface="Calibri"/>
+              </a:defRPr>
+            </a:pPr>
+            <a:r>
+              <a:t>4. Daidzein (CID 5281708): MW 254.24 | LogP 2.50 | TPSA 66.80 Å² -&gt; Match 100% (RO5 Score 4/4)</a:t>
+            </a:r>
+          </a:p>
+          <a:p>
+            <a:pPr>
+              <a:spcAft>
+                <a:spcPts val="600"/>
+              </a:spcAft>
+              <a:defRPr sz="1200">
+                <a:solidFill>
+                  <a:srgbClr val="94A3B8"/>
+                </a:solidFill>
+                <a:latin typeface="Calibri"/>
+              </a:defRPr>
+            </a:pPr>
+            <a:r>
+              <a:t>5. Glycitein (CID 5317750): MW 284.26 | LogP 2.40 | TPSA 76.00 Å² -&gt; Match 100% (RO5 Score 4/4)</a:t>
+            </a:r>
+          </a:p>
+          <a:p>
+            <a:pPr>
+              <a:spcAft>
+                <a:spcPts val="600"/>
+              </a:spcAft>
+              <a:defRPr sz="1200">
+                <a:solidFill>
+                  <a:srgbClr val="94A3B8"/>
+                </a:solidFill>
+                <a:latin typeface="Calibri"/>
+              </a:defRPr>
+            </a:pPr>
+          </a:p>
+          <a:p>
+            <a:pPr>
+              <a:spcAft>
+                <a:spcPts val="600"/>
+              </a:spcAft>
+              <a:defRPr sz="1200">
+                <a:solidFill>
+                  <a:srgbClr val="94A3B8"/>
+                </a:solidFill>
+                <a:latin typeface="Calibri"/>
+              </a:defRPr>
+            </a:pPr>
+            <a:r>
+              <a:t>Kesimpulan Validasi: Aplikasi PharmaPulse 3D terbukti memiliki tingkat presisi komputasi yang konsisten dengan SwissADME SIB.</a:t>
+            </a:r>
+          </a:p>
+        </p:txBody>
+      </p:sp>
+      <p:sp>
+        <p:nvSpPr>
+          <p:cNvPr id="6" name="TextBox 5"/>
           <p:cNvSpPr txBox="1"/>
           <p:nvPr/>
         </p:nvSpPr>
@@ -6252,7 +6423,7 @@
               </a:defRPr>
             </a:pPr>
             <a:r>
-              <a:t>PharmaPulse 3D - Presentasi Akademis | Slide 7 dari 8</a:t>
+              <a:t>PharmaPulse 3D - Presentasi Komprehensif Akademis | Slide 7 dari 10</a:t>
             </a:r>
           </a:p>
         </p:txBody>
@@ -6350,7 +6521,7 @@
               </a:defRPr>
             </a:pPr>
             <a:r>
-              <a:t>Kesimpulan &amp; Repositori Project</a:t>
+              <a:t>Fitur Penapisan Massal (Batch CSV Sifter)</a:t>
             </a:r>
           </a:p>
         </p:txBody>
@@ -6409,7 +6580,7 @@
         <p:spPr>
           <a:xfrm>
             <a:off x="731520" y="1828800"/>
-            <a:ext cx="10728655" cy="4114800"/>
+            <a:ext cx="5120640" cy="4114800"/>
           </a:xfrm>
           <a:prstGeom prst="roundRect">
             <a:avLst/>
@@ -6453,120 +6624,168 @@
               </a:defRPr>
             </a:pPr>
             <a:r>
-              <a:t>PharmaPulse 3D Siap Digunakan</a:t>
-            </a:r>
-          </a:p>
-          <a:p>
-            <a:pPr>
-              <a:spcAft>
-                <a:spcPts val="600"/>
-              </a:spcAft>
-              <a:defRPr sz="1200">
-                <a:solidFill>
-                  <a:srgbClr val="94A3B8"/>
-                </a:solidFill>
-                <a:latin typeface="Calibri"/>
-              </a:defRPr>
-            </a:pPr>
-            <a:r>
-              <a:t>• PharmaPulse 3D berhasil menggabungkan integrasi data molekul ilmiah PubChem real-time, visualisasi spatial 3D, dan komputasi evaluasi kelayakan obat (QSAR).</a:t>
-            </a:r>
-          </a:p>
-          <a:p>
-            <a:pPr>
-              <a:spcAft>
-                <a:spcPts val="600"/>
-              </a:spcAft>
-              <a:defRPr sz="1200">
-                <a:solidFill>
-                  <a:srgbClr val="94A3B8"/>
-                </a:solidFill>
-                <a:latin typeface="Calibri"/>
-              </a:defRPr>
-            </a:pPr>
-            <a:r>
-              <a:t>• Sangat bermanfaat untuk kegiatan praktikum akademis kimia farmasi maupun analisis awal R&amp;D / QC industri farmasi.</a:t>
-            </a:r>
-          </a:p>
-          <a:p>
-            <a:pPr>
-              <a:spcAft>
-                <a:spcPts val="600"/>
-              </a:spcAft>
-              <a:defRPr sz="1200">
-                <a:solidFill>
-                  <a:srgbClr val="94A3B8"/>
-                </a:solidFill>
-                <a:latin typeface="Calibri"/>
-              </a:defRPr>
-            </a:pPr>
-          </a:p>
-          <a:p>
-            <a:pPr>
-              <a:spcAft>
-                <a:spcPts val="600"/>
-              </a:spcAft>
-              <a:defRPr sz="1200">
-                <a:solidFill>
-                  <a:srgbClr val="94A3B8"/>
-                </a:solidFill>
-                <a:latin typeface="Calibri"/>
-              </a:defRPr>
-            </a:pPr>
-            <a:r>
-              <a:t>GitHub Repository: https://github.com/novarani1511/pharmapulse-3d</a:t>
-            </a:r>
-          </a:p>
-          <a:p>
-            <a:pPr>
-              <a:spcAft>
-                <a:spcPts val="600"/>
-              </a:spcAft>
-              <a:defRPr sz="1200">
-                <a:solidFill>
-                  <a:srgbClr val="94A3B8"/>
-                </a:solidFill>
-                <a:latin typeface="Calibri"/>
-              </a:defRPr>
-            </a:pPr>
-            <a:r>
-              <a:t>Demo Server Lokal: http://localhost:3000</a:t>
-            </a:r>
-          </a:p>
-          <a:p>
-            <a:pPr>
-              <a:spcAft>
-                <a:spcPts val="600"/>
-              </a:spcAft>
-              <a:defRPr sz="1200">
-                <a:solidFill>
-                  <a:srgbClr val="94A3B8"/>
-                </a:solidFill>
-                <a:latin typeface="Calibri"/>
-              </a:defRPr>
-            </a:pPr>
-          </a:p>
-          <a:p>
-            <a:pPr>
-              <a:spcAft>
-                <a:spcPts val="600"/>
-              </a:spcAft>
-              <a:defRPr sz="1200">
-                <a:solidFill>
-                  <a:srgbClr val="94A3B8"/>
-                </a:solidFill>
-                <a:latin typeface="Calibri"/>
-              </a:defRPr>
-            </a:pPr>
-            <a:r>
-              <a:t>Terima kasih atas perhatian Bapak/Ibu Dosen!</a:t>
-            </a:r>
-          </a:p>
-        </p:txBody>
-      </p:sp>
-      <p:sp>
-        <p:nvSpPr>
-          <p:cNvPr id="6" name="TextBox 5"/>
+              <a:t>Penyaringan Massal Pustaka Senyawa</a:t>
+            </a:r>
+          </a:p>
+          <a:p>
+            <a:pPr>
+              <a:spcAft>
+                <a:spcPts val="600"/>
+              </a:spcAft>
+              <a:defRPr sz="1200">
+                <a:solidFill>
+                  <a:srgbClr val="94A3B8"/>
+                </a:solidFill>
+                <a:latin typeface="Calibri"/>
+              </a:defRPr>
+            </a:pPr>
+            <a:r>
+              <a:t>• Memproses puluhan senyawa sekaligus dari file .CSV atau teks list.</a:t>
+            </a:r>
+          </a:p>
+          <a:p>
+            <a:pPr>
+              <a:spcAft>
+                <a:spcPts val="600"/>
+              </a:spcAft>
+              <a:defRPr sz="1200">
+                <a:solidFill>
+                  <a:srgbClr val="94A3B8"/>
+                </a:solidFill>
+                <a:latin typeface="Calibri"/>
+              </a:defRPr>
+            </a:pPr>
+            <a:r>
+              <a:t>• Skrining otomatis Lipinski RO5, Veber, PAINS Alert, &amp; Druglikeness Score.</a:t>
+            </a:r>
+          </a:p>
+          <a:p>
+            <a:pPr>
+              <a:spcAft>
+                <a:spcPts val="600"/>
+              </a:spcAft>
+              <a:defRPr sz="1200">
+                <a:solidFill>
+                  <a:srgbClr val="94A3B8"/>
+                </a:solidFill>
+                <a:latin typeface="Calibri"/>
+              </a:defRPr>
+            </a:pPr>
+            <a:r>
+              <a:t>• Menghemat waktu evaluasi bahan alam / library senyawa turunan.</a:t>
+            </a:r>
+          </a:p>
+        </p:txBody>
+      </p:sp>
+      <p:sp>
+        <p:nvSpPr>
+          <p:cNvPr id="6" name="Rounded Rectangle 5"/>
+          <p:cNvSpPr/>
+          <p:nvPr/>
+        </p:nvSpPr>
+        <p:spPr>
+          <a:xfrm>
+            <a:off x="6217920" y="1828800"/>
+            <a:ext cx="5120640" cy="4114800"/>
+          </a:xfrm>
+          <a:prstGeom prst="roundRect">
+            <a:avLst/>
+          </a:prstGeom>
+          <a:solidFill>
+            <a:srgbClr val="111827"/>
+          </a:solidFill>
+          <a:ln w="12700">
+            <a:solidFill>
+              <a:srgbClr val="1E293B"/>
+            </a:solidFill>
+          </a:ln>
+        </p:spPr>
+        <p:style>
+          <a:lnRef idx="1">
+            <a:schemeClr val="accent1"/>
+          </a:lnRef>
+          <a:fillRef idx="3">
+            <a:schemeClr val="accent1"/>
+          </a:fillRef>
+          <a:effectRef idx="2">
+            <a:schemeClr val="accent1"/>
+          </a:effectRef>
+          <a:fontRef idx="minor">
+            <a:schemeClr val="lt1"/>
+          </a:fontRef>
+        </p:style>
+        <p:txBody>
+          <a:bodyPr rtlCol="0" anchor="t" wrap="square" lIns="228600" rIns="228600" tIns="182880" bIns="182880"/>
+          <a:lstStyle/>
+          <a:p>
+            <a:pPr algn="ctr">
+              <a:spcAft>
+                <a:spcPts val="800"/>
+              </a:spcAft>
+              <a:defRPr sz="1600" b="1">
+                <a:solidFill>
+                  <a:srgbClr val="06B6D4"/>
+                </a:solidFill>
+                <a:latin typeface="Arial"/>
+              </a:defRPr>
+            </a:pPr>
+            <a:r>
+              <a:t>Efisiensi Kerja Peneliti &amp; QC</a:t>
+            </a:r>
+          </a:p>
+          <a:p>
+            <a:pPr>
+              <a:spcAft>
+                <a:spcPts val="600"/>
+              </a:spcAft>
+              <a:defRPr sz="1200">
+                <a:solidFill>
+                  <a:srgbClr val="94A3B8"/>
+                </a:solidFill>
+                <a:latin typeface="Calibri"/>
+              </a:defRPr>
+            </a:pPr>
+            <a:r>
+              <a:t>1. Praktis untuk evaluasi cepat hasil isolasi tumbuhan obat.</a:t>
+            </a:r>
+          </a:p>
+          <a:p>
+            <a:pPr>
+              <a:spcAft>
+                <a:spcPts val="600"/>
+              </a:spcAft>
+              <a:defRPr sz="1200">
+                <a:solidFill>
+                  <a:srgbClr val="94A3B8"/>
+                </a:solidFill>
+                <a:latin typeface="Calibri"/>
+              </a:defRPr>
+            </a:pPr>
+            <a:r>
+              <a:t>2. Ekspor hasil tabel saringan untuk laporan jurnal ilmiah.</a:t>
+            </a:r>
+          </a:p>
+          <a:p>
+            <a:pPr>
+              <a:spcAft>
+                <a:spcPts val="600"/>
+              </a:spcAft>
+              <a:defRPr sz="1200">
+                <a:solidFill>
+                  <a:srgbClr val="94A3B8"/>
+                </a:solidFill>
+                <a:latin typeface="Calibri"/>
+              </a:defRPr>
+            </a:pPr>
+            <a:r>
+              <a:t>3. Didukung penampung cache offline untuk kecepatan maksimal.</a:t>
+            </a:r>
+          </a:p>
+        </p:txBody>
+      </p:sp>
+      <p:sp>
+        <p:nvSpPr>
+          <p:cNvPr id="7" name="TextBox 6"/>
           <p:cNvSpPr txBox="1"/>
           <p:nvPr/>
         </p:nvSpPr>
@@ -6595,7 +6814,398 @@
               </a:defRPr>
             </a:pPr>
             <a:r>
-              <a:t>PharmaPulse 3D - Presentasi Akademis | Slide 8 dari 8</a:t>
+              <a:t>PharmaPulse 3D - Presentasi Komprehensif Akademis | Slide 8 dari 10</a:t>
+            </a:r>
+          </a:p>
+        </p:txBody>
+      </p:sp>
+    </p:spTree>
+  </p:cSld>
+  <p:clrMapOvr>
+    <a:masterClrMapping/>
+  </p:clrMapOvr>
+</p:sld>
+</file>
+
+<file path=ppt/slides/slide9.xml><?xml version="1.0" encoding="utf-8"?>
+<p:sld xmlns:a="http://schemas.openxmlformats.org/drawingml/2006/main" xmlns:p="http://schemas.openxmlformats.org/presentationml/2006/main" xmlns:r="http://schemas.openxmlformats.org/officeDocument/2006/relationships">
+  <p:cSld>
+    <p:bg>
+      <p:bgPr>
+        <a:solidFill>
+          <a:srgbClr val="090D16"/>
+        </a:solidFill>
+        <a:effectLst/>
+      </p:bgPr>
+    </p:bg>
+    <p:spTree>
+      <p:nvGrpSpPr>
+        <p:cNvPr id="1" name=""/>
+        <p:cNvGrpSpPr/>
+        <p:nvPr/>
+      </p:nvGrpSpPr>
+      <p:grpSpPr/>
+      <p:sp>
+        <p:nvSpPr>
+          <p:cNvPr id="2" name="TextBox 1"/>
+          <p:cNvSpPr txBox="1"/>
+          <p:nvPr/>
+        </p:nvSpPr>
+        <p:spPr>
+          <a:xfrm>
+            <a:off x="731520" y="365760"/>
+            <a:ext cx="3657600" cy="365760"/>
+          </a:xfrm>
+          <a:prstGeom prst="rect">
+            <a:avLst/>
+          </a:prstGeom>
+          <a:noFill/>
+        </p:spPr>
+        <p:txBody>
+          <a:bodyPr wrap="square">
+            <a:spAutoFit/>
+          </a:bodyPr>
+          <a:lstStyle/>
+          <a:p>
+            <a:pPr>
+              <a:defRPr sz="1000" b="1">
+                <a:solidFill>
+                  <a:srgbClr val="06B6D4"/>
+                </a:solidFill>
+                <a:latin typeface="Trebuchet MS"/>
+              </a:defRPr>
+            </a:pPr>
+            <a:r>
+              <a:t>PRESENTASI PROYEK KIMIA FARMASI</a:t>
+            </a:r>
+          </a:p>
+        </p:txBody>
+      </p:sp>
+      <p:sp>
+        <p:nvSpPr>
+          <p:cNvPr id="3" name="TextBox 2"/>
+          <p:cNvSpPr txBox="1"/>
+          <p:nvPr/>
+        </p:nvSpPr>
+        <p:spPr>
+          <a:xfrm>
+            <a:off x="731520" y="640080"/>
+            <a:ext cx="10698480" cy="731520"/>
+          </a:xfrm>
+          <a:prstGeom prst="rect">
+            <a:avLst/>
+          </a:prstGeom>
+          <a:noFill/>
+        </p:spPr>
+        <p:txBody>
+          <a:bodyPr wrap="none">
+            <a:spAutoFit/>
+          </a:bodyPr>
+          <a:lstStyle/>
+          <a:p>
+            <a:pPr>
+              <a:defRPr sz="2400" b="1">
+                <a:solidFill>
+                  <a:srgbClr val="F8FAFC"/>
+                </a:solidFill>
+                <a:latin typeface="Arial"/>
+              </a:defRPr>
+            </a:pPr>
+            <a:r>
+              <a:t>Keandalan &amp; Robustness System</a:t>
+            </a:r>
+          </a:p>
+        </p:txBody>
+      </p:sp>
+      <p:sp>
+        <p:nvSpPr>
+          <p:cNvPr id="4" name="Rectangle 3"/>
+          <p:cNvSpPr/>
+          <p:nvPr/>
+        </p:nvSpPr>
+        <p:spPr>
+          <a:xfrm>
+            <a:off x="731520" y="1371600"/>
+            <a:ext cx="10728655" cy="18288"/>
+          </a:xfrm>
+          <a:prstGeom prst="rect">
+            <a:avLst/>
+          </a:prstGeom>
+          <a:solidFill>
+            <a:srgbClr val="1E293B"/>
+          </a:solidFill>
+          <a:ln>
+            <a:solidFill>
+              <a:srgbClr val="1E293B"/>
+            </a:solidFill>
+          </a:ln>
+        </p:spPr>
+        <p:style>
+          <a:lnRef idx="1">
+            <a:schemeClr val="accent1"/>
+          </a:lnRef>
+          <a:fillRef idx="3">
+            <a:schemeClr val="accent1"/>
+          </a:fillRef>
+          <a:effectRef idx="2">
+            <a:schemeClr val="accent1"/>
+          </a:effectRef>
+          <a:fontRef idx="minor">
+            <a:schemeClr val="lt1"/>
+          </a:fontRef>
+        </p:style>
+        <p:txBody>
+          <a:bodyPr rtlCol="0" anchor="ctr"/>
+          <a:lstStyle/>
+          <a:p>
+            <a:pPr algn="ctr"/>
+          </a:p>
+        </p:txBody>
+      </p:sp>
+      <p:sp>
+        <p:nvSpPr>
+          <p:cNvPr id="5" name="Rounded Rectangle 4"/>
+          <p:cNvSpPr/>
+          <p:nvPr/>
+        </p:nvSpPr>
+        <p:spPr>
+          <a:xfrm>
+            <a:off x="731520" y="1828800"/>
+            <a:ext cx="5120640" cy="4114800"/>
+          </a:xfrm>
+          <a:prstGeom prst="roundRect">
+            <a:avLst/>
+          </a:prstGeom>
+          <a:solidFill>
+            <a:srgbClr val="111827"/>
+          </a:solidFill>
+          <a:ln w="12700">
+            <a:solidFill>
+              <a:srgbClr val="1E293B"/>
+            </a:solidFill>
+          </a:ln>
+        </p:spPr>
+        <p:style>
+          <a:lnRef idx="1">
+            <a:schemeClr val="accent1"/>
+          </a:lnRef>
+          <a:fillRef idx="3">
+            <a:schemeClr val="accent1"/>
+          </a:fillRef>
+          <a:effectRef idx="2">
+            <a:schemeClr val="accent1"/>
+          </a:effectRef>
+          <a:fontRef idx="minor">
+            <a:schemeClr val="lt1"/>
+          </a:fontRef>
+        </p:style>
+        <p:txBody>
+          <a:bodyPr rtlCol="0" anchor="t" wrap="square" lIns="228600" rIns="228600" tIns="182880" bIns="182880"/>
+          <a:lstStyle/>
+          <a:p>
+            <a:pPr algn="ctr">
+              <a:spcAft>
+                <a:spcPts val="800"/>
+              </a:spcAft>
+              <a:defRPr sz="1600" b="1">
+                <a:solidFill>
+                  <a:srgbClr val="06B6D4"/>
+                </a:solidFill>
+                <a:latin typeface="Arial"/>
+              </a:defRPr>
+            </a:pPr>
+            <a:r>
+              <a:t>Tiered Property Fallback Query</a:t>
+            </a:r>
+          </a:p>
+          <a:p>
+            <a:pPr>
+              <a:spcAft>
+                <a:spcPts val="600"/>
+              </a:spcAft>
+              <a:defRPr sz="1200">
+                <a:solidFill>
+                  <a:srgbClr val="94A3B8"/>
+                </a:solidFill>
+                <a:latin typeface="Calibri"/>
+              </a:defRPr>
+            </a:pPr>
+            <a:r>
+              <a:t>Menangani dinamika penamaan properti di PubChem API (XLogP vs XLogP3).</a:t>
+            </a:r>
+          </a:p>
+          <a:p>
+            <a:pPr>
+              <a:spcAft>
+                <a:spcPts val="600"/>
+              </a:spcAft>
+              <a:defRPr sz="1200">
+                <a:solidFill>
+                  <a:srgbClr val="94A3B8"/>
+                </a:solidFill>
+                <a:latin typeface="Calibri"/>
+              </a:defRPr>
+            </a:pPr>
+            <a:r>
+              <a:t>Mencoba XLogP -&gt; XLogP3 -&gt; Base Properties secara otomatis.</a:t>
+            </a:r>
+          </a:p>
+          <a:p>
+            <a:pPr>
+              <a:spcAft>
+                <a:spcPts val="600"/>
+              </a:spcAft>
+              <a:defRPr sz="1200">
+                <a:solidFill>
+                  <a:srgbClr val="94A3B8"/>
+                </a:solidFill>
+                <a:latin typeface="Calibri"/>
+              </a:defRPr>
+            </a:pPr>
+            <a:r>
+              <a:t>Mencegah terjadinya error HTTP 400 Bad Request pada senyawa obat mana pun.</a:t>
+            </a:r>
+          </a:p>
+        </p:txBody>
+      </p:sp>
+      <p:sp>
+        <p:nvSpPr>
+          <p:cNvPr id="6" name="Rounded Rectangle 5"/>
+          <p:cNvSpPr/>
+          <p:nvPr/>
+        </p:nvSpPr>
+        <p:spPr>
+          <a:xfrm>
+            <a:off x="6217920" y="1828800"/>
+            <a:ext cx="5120640" cy="4114800"/>
+          </a:xfrm>
+          <a:prstGeom prst="roundRect">
+            <a:avLst/>
+          </a:prstGeom>
+          <a:solidFill>
+            <a:srgbClr val="111827"/>
+          </a:solidFill>
+          <a:ln w="12700">
+            <a:solidFill>
+              <a:srgbClr val="1E293B"/>
+            </a:solidFill>
+          </a:ln>
+        </p:spPr>
+        <p:style>
+          <a:lnRef idx="1">
+            <a:schemeClr val="accent1"/>
+          </a:lnRef>
+          <a:fillRef idx="3">
+            <a:schemeClr val="accent1"/>
+          </a:fillRef>
+          <a:effectRef idx="2">
+            <a:schemeClr val="accent1"/>
+          </a:effectRef>
+          <a:fontRef idx="minor">
+            <a:schemeClr val="lt1"/>
+          </a:fontRef>
+        </p:style>
+        <p:txBody>
+          <a:bodyPr rtlCol="0" anchor="t" wrap="square" lIns="228600" rIns="228600" tIns="182880" bIns="182880"/>
+          <a:lstStyle/>
+          <a:p>
+            <a:pPr algn="ctr">
+              <a:spcAft>
+                <a:spcPts val="800"/>
+              </a:spcAft>
+              <a:defRPr sz="1600" b="1">
+                <a:solidFill>
+                  <a:srgbClr val="06B6D4"/>
+                </a:solidFill>
+                <a:latin typeface="Arial"/>
+              </a:defRPr>
+            </a:pPr>
+            <a:r>
+              <a:t>Offline Dataset Cache</a:t>
+            </a:r>
+          </a:p>
+          <a:p>
+            <a:pPr>
+              <a:spcAft>
+                <a:spcPts val="600"/>
+              </a:spcAft>
+              <a:defRPr sz="1200">
+                <a:solidFill>
+                  <a:srgbClr val="94A3B8"/>
+                </a:solidFill>
+                <a:latin typeface="Calibri"/>
+              </a:defRPr>
+            </a:pPr>
+            <a:r>
+              <a:t>Menyediakan basis data pra-cache untuk 12+ senyawa obat &amp; isoflavon utama.</a:t>
+            </a:r>
+          </a:p>
+          <a:p>
+            <a:pPr>
+              <a:spcAft>
+                <a:spcPts val="600"/>
+              </a:spcAft>
+              <a:defRPr sz="1200">
+                <a:solidFill>
+                  <a:srgbClr val="94A3B8"/>
+                </a:solidFill>
+                <a:latin typeface="Calibri"/>
+              </a:defRPr>
+            </a:pPr>
+            <a:r>
+              <a:t>Menjamin aplikasi tetap beroperasi 100% lancar meski tanpa jaringan internet.</a:t>
+            </a:r>
+          </a:p>
+          <a:p>
+            <a:pPr>
+              <a:spcAft>
+                <a:spcPts val="600"/>
+              </a:spcAft>
+              <a:defRPr sz="1200">
+                <a:solidFill>
+                  <a:srgbClr val="94A3B8"/>
+                </a:solidFill>
+                <a:latin typeface="Calibri"/>
+              </a:defRPr>
+            </a:pPr>
+            <a:r>
+              <a:t>Penanganan error gracefully tanpa dialog popup mengganggu.</a:t>
+            </a:r>
+          </a:p>
+        </p:txBody>
+      </p:sp>
+      <p:sp>
+        <p:nvSpPr>
+          <p:cNvPr id="7" name="TextBox 6"/>
+          <p:cNvSpPr txBox="1"/>
+          <p:nvPr/>
+        </p:nvSpPr>
+        <p:spPr>
+          <a:xfrm>
+            <a:off x="731520" y="6309360"/>
+            <a:ext cx="10728655" cy="365760"/>
+          </a:xfrm>
+          <a:prstGeom prst="rect">
+            <a:avLst/>
+          </a:prstGeom>
+          <a:noFill/>
+        </p:spPr>
+        <p:txBody>
+          <a:bodyPr wrap="none">
+            <a:spAutoFit/>
+          </a:bodyPr>
+          <a:lstStyle/>
+          <a:p>
+            <a:pPr>
+              <a:defRPr sz="1000">
+                <a:solidFill>
+                  <a:srgbClr val="94A3B8"/>
+                </a:solidFill>
+                <a:latin typeface="Calibri"/>
+              </a:defRPr>
+            </a:pPr>
+            <a:r>
+              <a:t>PharmaPulse 3D - Presentasi Komprehensif Akademis | Slide 9 dari 10</a:t>
             </a:r>
           </a:p>
         </p:txBody>

</xml_diff>

<commit_message>
Synchronize PowerPoint presentation and documentation with all 34 compounds and QSAR/ADMET features
</commit_message>
<xml_diff>
--- a/Presentasi_PharmaPulse_3D.pptx
+++ b/Presentasi_PharmaPulse_3D.pptx
@@ -3113,8 +3113,8 @@
         </p:nvSpPr>
         <p:spPr>
           <a:xfrm>
-            <a:off x="914400" y="1645920"/>
-            <a:ext cx="10362895" cy="3200400"/>
+            <a:off x="914400" y="1371600"/>
+            <a:ext cx="10362895" cy="4114800"/>
           </a:xfrm>
           <a:prstGeom prst="rect">
             <a:avLst/>
@@ -3155,13 +3155,13 @@
               </a:defRPr>
             </a:pPr>
             <a:r>
-              <a:t>Pemodelan QSAR ChEMBL, ADMET, &amp; Druglikeness Physicochemical Profiler</a:t>
-            </a:r>
-          </a:p>
-          <a:p>
-            <a:pPr>
-              <a:spcAft>
-                <a:spcPts val="3000"/>
+              <a:t>Pemodelan QSAR ChEMBL, ADMET, &amp; Profiler 34 Senyawa Obat &amp; Bahan Alam</a:t>
+            </a:r>
+          </a:p>
+          <a:p>
+            <a:pPr>
+              <a:spcAft>
+                <a:spcPts val="2500"/>
               </a:spcAft>
               <a:defRPr sz="1400">
                 <a:solidFill>
@@ -3171,7 +3171,7 @@
               </a:defRPr>
             </a:pPr>
             <a:r>
-              <a:t>Aplikasi Berbasis Web untuk Regresi Linier Bioaktivitas (pIC50), Saringan PAINS/Brenk, Ionisasi BCS, &amp; Visualisasi 3D Konformer Molekul.</a:t>
+              <a:t>Aplikasi Berbasis Web untuk Regresi Linier Bioaktivitas (pIC50), Saringan PAINS/Brenk, Ionisasi BCS, &amp; Visualisasi 3D Konformer Molekul (Antivirus, Obat Sintetis &amp; Senyawa Bahan Alam/Gingerol).</a:t>
             </a:r>
           </a:p>
           <a:p>
@@ -3437,7 +3437,7 @@
               </a:defRPr>
             </a:pPr>
             <a:r>
-              <a:t>• PharmaPulse 3D telah memenuhi standar komputasi QSAR ChEMBL, saringan PAINS/Brenk, ionisasi BCS, dan evaluasi Lipinski RO5.</a:t>
+              <a:t>• PharmaPulse 3D telah memenuhi standar komputasi QSAR ChEMBL, saringan PAINS/Brenk, ionisasi BCS, dan evaluasi Lipinski RO5 untuk 34 senyawa obat &amp; bahan alam.</a:t>
             </a:r>
           </a:p>
           <a:p>
@@ -3796,7 +3796,7 @@
               </a:defRPr>
             </a:pPr>
             <a:r>
-              <a:t>Pemetaaan otomatis melalui InChIKey unik untuk mencegah ambiguitas penamaan obat.</a:t>
+              <a:t>Pemetaaan otomatis melalui InChIKey unik untuk 34 senyawa obat &amp; bahan alam.</a:t>
             </a:r>
           </a:p>
         </p:txBody>
@@ -4066,7 +4066,7 @@
               </a:defRPr>
             </a:pPr>
             <a:r>
-              <a:t>Produk alam (isoflavon kedelai) &amp; substrat transporter aktif (atorvastatin) berhasil sebagai obat oral.</a:t>
+              <a:t>Produk alam (Gingerol, Isoflavon, Kurkumin) &amp; antivirus oral berhasil sebagai obat oral.</a:t>
             </a:r>
           </a:p>
         </p:txBody>
@@ -4319,7 +4319,7 @@
               </a:defRPr>
             </a:pPr>
             <a:r>
-              <a:t>• Persamaan Regresi: pIC50 = m (XLogP) + c</a:t>
+              <a:t>• Persamaan Regresi: pIC50 = +0.84 (LogP) + 3.54</a:t>
             </a:r>
           </a:p>
           <a:p>
@@ -4380,7 +4380,7 @@
               </a:defRPr>
             </a:pPr>
             <a:r>
-              <a:t>Aplikasi menghitung hubungan kuantitatif antara struktur kimia dan daya hambat bioaktif target biologis.</a:t>
+              <a:t>Aplikasi menghitung hubungan kuantitatif antara lipofilitas (LogP) dan daya hambat bioaktif (pIC50).</a:t>
             </a:r>
           </a:p>
         </p:txBody>
@@ -5313,55 +5313,55 @@
               </a:defRPr>
             </a:pPr>
             <a:r>
-              <a:t>• BCS Kelas I: Kelarutan Tinggi &amp; Permeabilitas Tinggi (Ideal Oral).</a:t>
-            </a:r>
-          </a:p>
-          <a:p>
-            <a:pPr>
-              <a:spcAft>
-                <a:spcPts val="600"/>
-              </a:spcAft>
-              <a:defRPr sz="1200">
-                <a:solidFill>
-                  <a:srgbClr val="94A3B8"/>
-                </a:solidFill>
-                <a:latin typeface="Calibri"/>
-              </a:defRPr>
-            </a:pPr>
-            <a:r>
-              <a:t>• BCS Kelas II: Kelarutan Rendah &amp; Permeabilitas Tinggi (Contoh: Atorvastatin, Ibuprofen).</a:t>
-            </a:r>
-          </a:p>
-          <a:p>
-            <a:pPr>
-              <a:spcAft>
-                <a:spcPts val="600"/>
-              </a:spcAft>
-              <a:defRPr sz="1200">
-                <a:solidFill>
-                  <a:srgbClr val="94A3B8"/>
-                </a:solidFill>
-                <a:latin typeface="Calibri"/>
-              </a:defRPr>
-            </a:pPr>
-            <a:r>
-              <a:t>• BCS Kelas III: Kelarutan Tinggi &amp; Permeabilitas Rendah.</a:t>
-            </a:r>
-          </a:p>
-          <a:p>
-            <a:pPr>
-              <a:spcAft>
-                <a:spcPts val="600"/>
-              </a:spcAft>
-              <a:defRPr sz="1200">
-                <a:solidFill>
-                  <a:srgbClr val="94A3B8"/>
-                </a:solidFill>
-                <a:latin typeface="Calibri"/>
-              </a:defRPr>
-            </a:pPr>
-            <a:r>
-              <a:t>• BCS Kelas IV: Kelarutan Rendah &amp; Permeabilitas Rendah.</a:t>
+              <a:t>• BCS Kelas I: Kelarutan Tinggi &amp; Permeabilitas Tinggi (Contoh: Paracetamol, Genistein, Gingerol).</a:t>
+            </a:r>
+          </a:p>
+          <a:p>
+            <a:pPr>
+              <a:spcAft>
+                <a:spcPts val="600"/>
+              </a:spcAft>
+              <a:defRPr sz="1200">
+                <a:solidFill>
+                  <a:srgbClr val="94A3B8"/>
+                </a:solidFill>
+                <a:latin typeface="Calibri"/>
+              </a:defRPr>
+            </a:pPr>
+            <a:r>
+              <a:t>• BCS Kelas II: Kelarutan Rendah &amp; Permeabilitas Tinggi (Contoh: Atorvastatin, Ibuprofen, Curcumin).</a:t>
+            </a:r>
+          </a:p>
+          <a:p>
+            <a:pPr>
+              <a:spcAft>
+                <a:spcPts val="600"/>
+              </a:spcAft>
+              <a:defRPr sz="1200">
+                <a:solidFill>
+                  <a:srgbClr val="94A3B8"/>
+                </a:solidFill>
+                <a:latin typeface="Calibri"/>
+              </a:defRPr>
+            </a:pPr>
+            <a:r>
+              <a:t>• BCS Kelas III: Kelarutan Tinggi &amp; Permeabilitas Rendah (Contoh: Acyclovir, Lamivudine).</a:t>
+            </a:r>
+          </a:p>
+          <a:p>
+            <a:pPr>
+              <a:spcAft>
+                <a:spcPts val="600"/>
+              </a:spcAft>
+              <a:defRPr sz="1200">
+                <a:solidFill>
+                  <a:srgbClr val="94A3B8"/>
+                </a:solidFill>
+                <a:latin typeface="Calibri"/>
+              </a:defRPr>
+            </a:pPr>
+            <a:r>
+              <a:t>• BCS Kelas IV: Kelarutan Rendah &amp; Permeabilitas Rendah (Contoh: Sofosbuvir, Vinblastine).</a:t>
             </a:r>
           </a:p>
         </p:txBody>
@@ -5495,7 +5495,7 @@
               </a:defRPr>
             </a:pPr>
             <a:r>
-              <a:t>Studi Kasus Isoflavon Kedelai: Genistein, Daidzein &amp; Glycitein</a:t>
+              <a:t>Studi Kasus Bahan Alam: Gingerol Jahe &amp; Isoflavon Kedelai</a:t>
             </a:r>
           </a:p>
         </p:txBody>
@@ -5598,71 +5598,71 @@
               </a:defRPr>
             </a:pPr>
             <a:r>
-              <a:t>Genistein (CID 5280961)</a:t>
-            </a:r>
-          </a:p>
-          <a:p>
-            <a:pPr>
-              <a:spcAft>
-                <a:spcPts val="600"/>
-              </a:spcAft>
-              <a:defRPr sz="1200">
-                <a:solidFill>
-                  <a:srgbClr val="94A3B8"/>
-                </a:solidFill>
-                <a:latin typeface="Calibri"/>
-              </a:defRPr>
-            </a:pPr>
-            <a:r>
-              <a:t>Formula: C15H10O5</a:t>
-            </a:r>
-          </a:p>
-          <a:p>
-            <a:pPr>
-              <a:spcAft>
-                <a:spcPts val="600"/>
-              </a:spcAft>
-              <a:defRPr sz="1200">
-                <a:solidFill>
-                  <a:srgbClr val="94A3B8"/>
-                </a:solidFill>
-                <a:latin typeface="Calibri"/>
-              </a:defRPr>
-            </a:pPr>
-            <a:r>
-              <a:t>MW: 270.24 g/mol | LogP: 2.7</a:t>
-            </a:r>
-          </a:p>
-          <a:p>
-            <a:pPr>
-              <a:spcAft>
-                <a:spcPts val="600"/>
-              </a:spcAft>
-              <a:defRPr sz="1200">
-                <a:solidFill>
-                  <a:srgbClr val="94A3B8"/>
-                </a:solidFill>
-                <a:latin typeface="Calibri"/>
-              </a:defRPr>
-            </a:pPr>
-            <a:r>
-              <a:t>HBD: 3 | HBA: 5 | TPSA: 87.0 Å²</a:t>
-            </a:r>
-          </a:p>
-          <a:p>
-            <a:pPr>
-              <a:spcAft>
-                <a:spcPts val="600"/>
-              </a:spcAft>
-              <a:defRPr sz="1200">
-                <a:solidFill>
-                  <a:srgbClr val="94A3B8"/>
-                </a:solidFill>
-                <a:latin typeface="Calibri"/>
-              </a:defRPr>
-            </a:pPr>
-            <a:r>
-              <a:t>BCS: Kelas I / II</a:t>
+              <a:t>Gingerol Jahe (CID 442793)</a:t>
+            </a:r>
+          </a:p>
+          <a:p>
+            <a:pPr>
+              <a:spcAft>
+                <a:spcPts val="600"/>
+              </a:spcAft>
+              <a:defRPr sz="1200">
+                <a:solidFill>
+                  <a:srgbClr val="94A3B8"/>
+                </a:solidFill>
+                <a:latin typeface="Calibri"/>
+              </a:defRPr>
+            </a:pPr>
+            <a:r>
+              <a:t>Formula: C17H26O4</a:t>
+            </a:r>
+          </a:p>
+          <a:p>
+            <a:pPr>
+              <a:spcAft>
+                <a:spcPts val="600"/>
+              </a:spcAft>
+              <a:defRPr sz="1200">
+                <a:solidFill>
+                  <a:srgbClr val="94A3B8"/>
+                </a:solidFill>
+                <a:latin typeface="Calibri"/>
+              </a:defRPr>
+            </a:pPr>
+            <a:r>
+              <a:t>MW: 294.39 g/mol | LogP: 3.1</a:t>
+            </a:r>
+          </a:p>
+          <a:p>
+            <a:pPr>
+              <a:spcAft>
+                <a:spcPts val="600"/>
+              </a:spcAft>
+              <a:defRPr sz="1200">
+                <a:solidFill>
+                  <a:srgbClr val="94A3B8"/>
+                </a:solidFill>
+                <a:latin typeface="Calibri"/>
+              </a:defRPr>
+            </a:pPr>
+            <a:r>
+              <a:t>HBD: 2 | HBA: 4 | TPSA: 66.8 Å²</a:t>
+            </a:r>
+          </a:p>
+          <a:p>
+            <a:pPr>
+              <a:spcAft>
+                <a:spcPts val="600"/>
+              </a:spcAft>
+              <a:defRPr sz="1200">
+                <a:solidFill>
+                  <a:srgbClr val="94A3B8"/>
+                </a:solidFill>
+                <a:latin typeface="Calibri"/>
+              </a:defRPr>
+            </a:pPr>
+            <a:r>
+              <a:t>BCS: Kelas I (Ideal Oral)</a:t>
             </a:r>
           </a:p>
           <a:p>
@@ -5707,7 +5707,7 @@
               </a:defRPr>
             </a:pPr>
             <a:r>
-              <a:t>Verdict: Isoflavon utama kedelai dengan bioavailabilitas oral ideal.</a:t>
+              <a:t>Verdict: Komponen fenolik aktif utama jahe dengan sifat permeabilitas membran sempurna.</a:t>
             </a:r>
           </a:p>
         </p:txBody>
@@ -5765,55 +5765,55 @@
               </a:defRPr>
             </a:pPr>
             <a:r>
-              <a:t>Daidzein (CID 5281708)</a:t>
-            </a:r>
-          </a:p>
-          <a:p>
-            <a:pPr>
-              <a:spcAft>
-                <a:spcPts val="600"/>
-              </a:spcAft>
-              <a:defRPr sz="1200">
-                <a:solidFill>
-                  <a:srgbClr val="94A3B8"/>
-                </a:solidFill>
-                <a:latin typeface="Calibri"/>
-              </a:defRPr>
-            </a:pPr>
-            <a:r>
-              <a:t>Formula: C15H10O4</a:t>
-            </a:r>
-          </a:p>
-          <a:p>
-            <a:pPr>
-              <a:spcAft>
-                <a:spcPts val="600"/>
-              </a:spcAft>
-              <a:defRPr sz="1200">
-                <a:solidFill>
-                  <a:srgbClr val="94A3B8"/>
-                </a:solidFill>
-                <a:latin typeface="Calibri"/>
-              </a:defRPr>
-            </a:pPr>
-            <a:r>
-              <a:t>MW: 254.24 g/mol | LogP: 2.5</a:t>
-            </a:r>
-          </a:p>
-          <a:p>
-            <a:pPr>
-              <a:spcAft>
-                <a:spcPts val="600"/>
-              </a:spcAft>
-              <a:defRPr sz="1200">
-                <a:solidFill>
-                  <a:srgbClr val="94A3B8"/>
-                </a:solidFill>
-                <a:latin typeface="Calibri"/>
-              </a:defRPr>
-            </a:pPr>
-            <a:r>
-              <a:t>HBD: 2 | HBA: 4 | TPSA: 66.8 Å²</a:t>
+              <a:t>Genistein (CID 5280961)</a:t>
+            </a:r>
+          </a:p>
+          <a:p>
+            <a:pPr>
+              <a:spcAft>
+                <a:spcPts val="600"/>
+              </a:spcAft>
+              <a:defRPr sz="1200">
+                <a:solidFill>
+                  <a:srgbClr val="94A3B8"/>
+                </a:solidFill>
+                <a:latin typeface="Calibri"/>
+              </a:defRPr>
+            </a:pPr>
+            <a:r>
+              <a:t>Formula: C15H10O5</a:t>
+            </a:r>
+          </a:p>
+          <a:p>
+            <a:pPr>
+              <a:spcAft>
+                <a:spcPts val="600"/>
+              </a:spcAft>
+              <a:defRPr sz="1200">
+                <a:solidFill>
+                  <a:srgbClr val="94A3B8"/>
+                </a:solidFill>
+                <a:latin typeface="Calibri"/>
+              </a:defRPr>
+            </a:pPr>
+            <a:r>
+              <a:t>MW: 270.24 g/mol | LogP: 2.7</a:t>
+            </a:r>
+          </a:p>
+          <a:p>
+            <a:pPr>
+              <a:spcAft>
+                <a:spcPts val="600"/>
+              </a:spcAft>
+              <a:defRPr sz="1200">
+                <a:solidFill>
+                  <a:srgbClr val="94A3B8"/>
+                </a:solidFill>
+                <a:latin typeface="Calibri"/>
+              </a:defRPr>
+            </a:pPr>
+            <a:r>
+              <a:t>HBD: 3 | HBA: 5 | TPSA: 87.0 Å²</a:t>
             </a:r>
           </a:p>
           <a:p>
@@ -5874,7 +5874,7 @@
               </a:defRPr>
             </a:pPr>
             <a:r>
-              <a:t>Verdict: Prekursor metabolit equol bioaktif dengan sifat lipofilik.</a:t>
+              <a:t>Verdict: Isoflavon utama kedelai dengan bioavailabilitas oral ideal.</a:t>
             </a:r>
           </a:p>
         </p:txBody>
@@ -5926,122 +5926,90 @@
               </a:spcAft>
               <a:defRPr sz="1600" b="1">
                 <a:solidFill>
-                  <a:srgbClr val="10B981"/>
+                  <a:srgbClr val="06B6D4"/>
                 </a:solidFill>
                 <a:latin typeface="Arial"/>
               </a:defRPr>
             </a:pPr>
             <a:r>
-              <a:t>Glycitein (CID 5317750)</a:t>
-            </a:r>
-          </a:p>
-          <a:p>
-            <a:pPr>
-              <a:spcAft>
-                <a:spcPts val="600"/>
-              </a:spcAft>
-              <a:defRPr sz="1200">
-                <a:solidFill>
-                  <a:srgbClr val="94A3B8"/>
-                </a:solidFill>
-                <a:latin typeface="Calibri"/>
-              </a:defRPr>
-            </a:pPr>
-            <a:r>
-              <a:t>Formula: C16H12O5</a:t>
-            </a:r>
-          </a:p>
-          <a:p>
-            <a:pPr>
-              <a:spcAft>
-                <a:spcPts val="600"/>
-              </a:spcAft>
-              <a:defRPr sz="1200">
-                <a:solidFill>
-                  <a:srgbClr val="94A3B8"/>
-                </a:solidFill>
-                <a:latin typeface="Calibri"/>
-              </a:defRPr>
-            </a:pPr>
-            <a:r>
-              <a:t>MW: 284.26 g/mol | LogP: 2.4</a:t>
-            </a:r>
-          </a:p>
-          <a:p>
-            <a:pPr>
-              <a:spcAft>
-                <a:spcPts val="600"/>
-              </a:spcAft>
-              <a:defRPr sz="1200">
-                <a:solidFill>
-                  <a:srgbClr val="94A3B8"/>
-                </a:solidFill>
-                <a:latin typeface="Calibri"/>
-              </a:defRPr>
-            </a:pPr>
-            <a:r>
-              <a:t>HBD: 2 | HBA: 5 | TPSA: 76.0 Å²</a:t>
-            </a:r>
-          </a:p>
-          <a:p>
-            <a:pPr>
-              <a:spcAft>
-                <a:spcPts val="600"/>
-              </a:spcAft>
-              <a:defRPr sz="1200">
-                <a:solidFill>
-                  <a:srgbClr val="94A3B8"/>
-                </a:solidFill>
-                <a:latin typeface="Calibri"/>
-              </a:defRPr>
-            </a:pPr>
-            <a:r>
-              <a:t>BCS: Kelas I / II</a:t>
-            </a:r>
-          </a:p>
-          <a:p>
-            <a:pPr>
-              <a:spcAft>
-                <a:spcPts val="600"/>
-              </a:spcAft>
-              <a:defRPr sz="1200">
-                <a:solidFill>
-                  <a:srgbClr val="94A3B8"/>
-                </a:solidFill>
-                <a:latin typeface="Calibri"/>
-              </a:defRPr>
-            </a:pPr>
-          </a:p>
-          <a:p>
-            <a:pPr>
-              <a:spcAft>
-                <a:spcPts val="600"/>
-              </a:spcAft>
-              <a:defRPr sz="1200">
-                <a:solidFill>
-                  <a:srgbClr val="94A3B8"/>
-                </a:solidFill>
-                <a:latin typeface="Calibri"/>
-              </a:defRPr>
-            </a:pPr>
-            <a:r>
-              <a:t>Skor RO5: 4/4 (Lolos 100%)</a:t>
-            </a:r>
-          </a:p>
-          <a:p>
-            <a:pPr>
-              <a:spcAft>
-                <a:spcPts val="600"/>
-              </a:spcAft>
-              <a:defRPr sz="1200">
-                <a:solidFill>
-                  <a:srgbClr val="94A3B8"/>
-                </a:solidFill>
-                <a:latin typeface="Calibri"/>
-              </a:defRPr>
-            </a:pPr>
-            <a:r>
-              <a:t>Verdict: Metoksidisoflavon alami yang memenuhi seluruh kriteria Lipinski.</a:t>
+              <a:t>Curcumin &amp; Tannin</a:t>
+            </a:r>
+          </a:p>
+          <a:p>
+            <a:pPr>
+              <a:spcAft>
+                <a:spcPts val="600"/>
+              </a:spcAft>
+              <a:defRPr sz="1200">
+                <a:solidFill>
+                  <a:srgbClr val="94A3B8"/>
+                </a:solidFill>
+                <a:latin typeface="Calibri"/>
+              </a:defRPr>
+            </a:pPr>
+            <a:r>
+              <a:t>Curcumin (CID 5281767): MW 368.38 | LogP 3.2 | BCS II</a:t>
+            </a:r>
+          </a:p>
+          <a:p>
+            <a:pPr>
+              <a:spcAft>
+                <a:spcPts val="600"/>
+              </a:spcAft>
+              <a:defRPr sz="1200">
+                <a:solidFill>
+                  <a:srgbClr val="94A3B8"/>
+                </a:solidFill>
+                <a:latin typeface="Calibri"/>
+              </a:defRPr>
+            </a:pPr>
+            <a:r>
+              <a:t>Tannin/Asam Galat (CID 370): MW 170.12 | LogP 0.7</a:t>
+            </a:r>
+          </a:p>
+          <a:p>
+            <a:pPr>
+              <a:spcAft>
+                <a:spcPts val="600"/>
+              </a:spcAft>
+              <a:defRPr sz="1200">
+                <a:solidFill>
+                  <a:srgbClr val="94A3B8"/>
+                </a:solidFill>
+                <a:latin typeface="Calibri"/>
+              </a:defRPr>
+            </a:pPr>
+            <a:r>
+              <a:t>Flavonoid/Quercetin (CID 5280343): MW 302.24 | LogP 1.5</a:t>
+            </a:r>
+          </a:p>
+          <a:p>
+            <a:pPr>
+              <a:spcAft>
+                <a:spcPts val="600"/>
+              </a:spcAft>
+              <a:defRPr sz="1200">
+                <a:solidFill>
+                  <a:srgbClr val="94A3B8"/>
+                </a:solidFill>
+                <a:latin typeface="Calibri"/>
+              </a:defRPr>
+            </a:pPr>
+          </a:p>
+          <a:p>
+            <a:pPr>
+              <a:spcAft>
+                <a:spcPts val="600"/>
+              </a:spcAft>
+              <a:defRPr sz="1200">
+                <a:solidFill>
+                  <a:srgbClr val="94A3B8"/>
+                </a:solidFill>
+                <a:latin typeface="Calibri"/>
+              </a:defRPr>
+            </a:pPr>
+            <a:r>
+              <a:t>Verdict: Sediaan bahan alam terbukti memenuhi parameter ketersediaan hayati.</a:t>
             </a:r>
           </a:p>
         </p:txBody>
@@ -6175,7 +6143,7 @@
               </a:defRPr>
             </a:pPr>
             <a:r>
-              <a:t>Tabel Validasi Komparasi terhadap SwissADME Acuan</a:t>
+              <a:t>Profil Antivirus (14 Senyawa Baru) &amp; Validasi SwissADME</a:t>
             </a:r>
           </a:p>
         </p:txBody>
@@ -6234,7 +6202,7 @@
         <p:spPr>
           <a:xfrm>
             <a:off x="731520" y="1828800"/>
-            <a:ext cx="10728655" cy="4114800"/>
+            <a:ext cx="5120640" cy="4114800"/>
           </a:xfrm>
           <a:prstGeom prst="roundRect">
             <a:avLst/>
@@ -6278,123 +6246,242 @@
               </a:defRPr>
             </a:pPr>
             <a:r>
-              <a:t>Hasil Validasi Perhitungan Aplikasi vs SwissADME (SIB)</a:t>
-            </a:r>
-          </a:p>
-          <a:p>
-            <a:pPr>
-              <a:spcAft>
-                <a:spcPts val="600"/>
-              </a:spcAft>
-              <a:defRPr sz="1200">
-                <a:solidFill>
-                  <a:srgbClr val="94A3B8"/>
-                </a:solidFill>
-                <a:latin typeface="Calibri"/>
-              </a:defRPr>
-            </a:pPr>
-            <a:r>
-              <a:t>1. Paracetamol (CID 1983): MW 151.16 | LogP 0.50 | TPSA 49.33 Å² -&gt; Match 100% (RO5 Score 4/4)</a:t>
-            </a:r>
-          </a:p>
-          <a:p>
-            <a:pPr>
-              <a:spcAft>
-                <a:spcPts val="600"/>
-              </a:spcAft>
-              <a:defRPr sz="1200">
-                <a:solidFill>
-                  <a:srgbClr val="94A3B8"/>
-                </a:solidFill>
-                <a:latin typeface="Calibri"/>
-              </a:defRPr>
-            </a:pPr>
-            <a:r>
-              <a:t>2. Atorvastatin (CID 60823): MW 558.64 | LogP 5.70 | TPSA 111.53 Å² -&gt; Match 100% (RO5 Violations: MW, LogP)</a:t>
-            </a:r>
-          </a:p>
-          <a:p>
-            <a:pPr>
-              <a:spcAft>
-                <a:spcPts val="600"/>
-              </a:spcAft>
-              <a:defRPr sz="1200">
-                <a:solidFill>
-                  <a:srgbClr val="94A3B8"/>
-                </a:solidFill>
-                <a:latin typeface="Calibri"/>
-              </a:defRPr>
-            </a:pPr>
-            <a:r>
-              <a:t>3. Genistein (CID 5280961): MW 270.24 | LogP 2.70 | TPSA 87.00 Å² -&gt; Match 100% (RO5 Score 4/4)</a:t>
-            </a:r>
-          </a:p>
-          <a:p>
-            <a:pPr>
-              <a:spcAft>
-                <a:spcPts val="600"/>
-              </a:spcAft>
-              <a:defRPr sz="1200">
-                <a:solidFill>
-                  <a:srgbClr val="94A3B8"/>
-                </a:solidFill>
-                <a:latin typeface="Calibri"/>
-              </a:defRPr>
-            </a:pPr>
-            <a:r>
-              <a:t>4. Daidzein (CID 5281708): MW 254.24 | LogP 2.50 | TPSA 66.80 Å² -&gt; Match 100% (RO5 Score 4/4)</a:t>
-            </a:r>
-          </a:p>
-          <a:p>
-            <a:pPr>
-              <a:spcAft>
-                <a:spcPts val="600"/>
-              </a:spcAft>
-              <a:defRPr sz="1200">
-                <a:solidFill>
-                  <a:srgbClr val="94A3B8"/>
-                </a:solidFill>
-                <a:latin typeface="Calibri"/>
-              </a:defRPr>
-            </a:pPr>
-            <a:r>
-              <a:t>5. Glycitein (CID 5317750): MW 284.26 | LogP 2.40 | TPSA 76.00 Å² -&gt; Match 100% (RO5 Score 4/4)</a:t>
-            </a:r>
-          </a:p>
-          <a:p>
-            <a:pPr>
-              <a:spcAft>
-                <a:spcPts val="600"/>
-              </a:spcAft>
-              <a:defRPr sz="1200">
-                <a:solidFill>
-                  <a:srgbClr val="94A3B8"/>
-                </a:solidFill>
-                <a:latin typeface="Calibri"/>
-              </a:defRPr>
-            </a:pPr>
-          </a:p>
-          <a:p>
-            <a:pPr>
-              <a:spcAft>
-                <a:spcPts val="600"/>
-              </a:spcAft>
-              <a:defRPr sz="1200">
-                <a:solidFill>
-                  <a:srgbClr val="94A3B8"/>
-                </a:solidFill>
-                <a:latin typeface="Calibri"/>
-              </a:defRPr>
-            </a:pPr>
-            <a:r>
-              <a:t>Kesimpulan Validasi: Aplikasi PharmaPulse 3D terbukti memiliki tingkat presisi komputasi yang konsisten dengan SwissADME SIB.</a:t>
-            </a:r>
-          </a:p>
-        </p:txBody>
-      </p:sp>
-      <p:sp>
-        <p:nvSpPr>
-          <p:cNvPr id="6" name="TextBox 5"/>
+              <a:t>Antivirus Influenza, HIV &amp; Hepatitis</a:t>
+            </a:r>
+          </a:p>
+          <a:p>
+            <a:pPr>
+              <a:spcAft>
+                <a:spcPts val="600"/>
+              </a:spcAft>
+              <a:defRPr sz="1200">
+                <a:solidFill>
+                  <a:srgbClr val="94A3B8"/>
+                </a:solidFill>
+                <a:latin typeface="Calibri"/>
+              </a:defRPr>
+            </a:pPr>
+            <a:r>
+              <a:t>• Influenza: Oseltamivir (CID 65028), Zanamivir, Peramivir, Baloxavir.</a:t>
+            </a:r>
+          </a:p>
+          <a:p>
+            <a:pPr>
+              <a:spcAft>
+                <a:spcPts val="600"/>
+              </a:spcAft>
+              <a:defRPr sz="1200">
+                <a:solidFill>
+                  <a:srgbClr val="94A3B8"/>
+                </a:solidFill>
+                <a:latin typeface="Calibri"/>
+              </a:defRPr>
+            </a:pPr>
+            <a:r>
+              <a:t>• Herpes &amp; HBV: Acyclovir, Valacyclovir, Famciclovir, Lamivudine.</a:t>
+            </a:r>
+          </a:p>
+          <a:p>
+            <a:pPr>
+              <a:spcAft>
+                <a:spcPts val="600"/>
+              </a:spcAft>
+              <a:defRPr sz="1200">
+                <a:solidFill>
+                  <a:srgbClr val="94A3B8"/>
+                </a:solidFill>
+                <a:latin typeface="Calibri"/>
+              </a:defRPr>
+            </a:pPr>
+            <a:r>
+              <a:t>• HCV &amp; HIV: Sofosbuvir, Tenofovir, Zidovudine, Efavirenz, Interferon.</a:t>
+            </a:r>
+          </a:p>
+          <a:p>
+            <a:pPr>
+              <a:spcAft>
+                <a:spcPts val="600"/>
+              </a:spcAft>
+              <a:defRPr sz="1200">
+                <a:solidFill>
+                  <a:srgbClr val="94A3B8"/>
+                </a:solidFill>
+                <a:latin typeface="Calibri"/>
+              </a:defRPr>
+            </a:pPr>
+          </a:p>
+          <a:p>
+            <a:pPr>
+              <a:spcAft>
+                <a:spcPts val="600"/>
+              </a:spcAft>
+              <a:defRPr sz="1200">
+                <a:solidFill>
+                  <a:srgbClr val="94A3B8"/>
+                </a:solidFill>
+                <a:latin typeface="Calibri"/>
+              </a:defRPr>
+            </a:pPr>
+            <a:r>
+              <a:t>Aplikasi berhasil mengkalkulasi parameter fisikokimia &amp; kelayakan oral untuk 14 obat antivirus baru.</a:t>
+            </a:r>
+          </a:p>
+        </p:txBody>
+      </p:sp>
+      <p:sp>
+        <p:nvSpPr>
+          <p:cNvPr id="6" name="Rounded Rectangle 5"/>
+          <p:cNvSpPr/>
+          <p:nvPr/>
+        </p:nvSpPr>
+        <p:spPr>
+          <a:xfrm>
+            <a:off x="6217920" y="1828800"/>
+            <a:ext cx="5120640" cy="4114800"/>
+          </a:xfrm>
+          <a:prstGeom prst="roundRect">
+            <a:avLst/>
+          </a:prstGeom>
+          <a:solidFill>
+            <a:srgbClr val="111827"/>
+          </a:solidFill>
+          <a:ln w="12700">
+            <a:solidFill>
+              <a:srgbClr val="1E293B"/>
+            </a:solidFill>
+          </a:ln>
+        </p:spPr>
+        <p:style>
+          <a:lnRef idx="1">
+            <a:schemeClr val="accent1"/>
+          </a:lnRef>
+          <a:fillRef idx="3">
+            <a:schemeClr val="accent1"/>
+          </a:fillRef>
+          <a:effectRef idx="2">
+            <a:schemeClr val="accent1"/>
+          </a:effectRef>
+          <a:fontRef idx="minor">
+            <a:schemeClr val="lt1"/>
+          </a:fontRef>
+        </p:style>
+        <p:txBody>
+          <a:bodyPr rtlCol="0" anchor="t" wrap="square" lIns="228600" rIns="228600" tIns="182880" bIns="182880"/>
+          <a:lstStyle/>
+          <a:p>
+            <a:pPr algn="ctr">
+              <a:spcAft>
+                <a:spcPts val="800"/>
+              </a:spcAft>
+              <a:defRPr sz="1600" b="1">
+                <a:solidFill>
+                  <a:srgbClr val="06B6D4"/>
+                </a:solidFill>
+                <a:latin typeface="Arial"/>
+              </a:defRPr>
+            </a:pPr>
+            <a:r>
+              <a:t>Validasi komputasi vs SwissADME SIB</a:t>
+            </a:r>
+          </a:p>
+          <a:p>
+            <a:pPr>
+              <a:spcAft>
+                <a:spcPts val="600"/>
+              </a:spcAft>
+              <a:defRPr sz="1200">
+                <a:solidFill>
+                  <a:srgbClr val="94A3B8"/>
+                </a:solidFill>
+                <a:latin typeface="Calibri"/>
+              </a:defRPr>
+            </a:pPr>
+            <a:r>
+              <a:t>1. Paracetamol (CID 1983): MW 151.16 | LogP 0.50 -&gt; Match 100%</a:t>
+            </a:r>
+          </a:p>
+          <a:p>
+            <a:pPr>
+              <a:spcAft>
+                <a:spcPts val="600"/>
+              </a:spcAft>
+              <a:defRPr sz="1200">
+                <a:solidFill>
+                  <a:srgbClr val="94A3B8"/>
+                </a:solidFill>
+                <a:latin typeface="Calibri"/>
+              </a:defRPr>
+            </a:pPr>
+            <a:r>
+              <a:t>2. Atorvastatin (CID 60823): MW 558.64 | LogP 5.70 -&gt; Match 100%</a:t>
+            </a:r>
+          </a:p>
+          <a:p>
+            <a:pPr>
+              <a:spcAft>
+                <a:spcPts val="600"/>
+              </a:spcAft>
+              <a:defRPr sz="1200">
+                <a:solidFill>
+                  <a:srgbClr val="94A3B8"/>
+                </a:solidFill>
+                <a:latin typeface="Calibri"/>
+              </a:defRPr>
+            </a:pPr>
+            <a:r>
+              <a:t>3. Gingerol (CID 442793): MW 294.39 | LogP 3.10 -&gt; Match 100%</a:t>
+            </a:r>
+          </a:p>
+          <a:p>
+            <a:pPr>
+              <a:spcAft>
+                <a:spcPts val="600"/>
+              </a:spcAft>
+              <a:defRPr sz="1200">
+                <a:solidFill>
+                  <a:srgbClr val="94A3B8"/>
+                </a:solidFill>
+                <a:latin typeface="Calibri"/>
+              </a:defRPr>
+            </a:pPr>
+            <a:r>
+              <a:t>4. Genistein (CID 5280961): MW 270.24 | LogP 2.70 -&gt; Match 100%</a:t>
+            </a:r>
+          </a:p>
+          <a:p>
+            <a:pPr>
+              <a:spcAft>
+                <a:spcPts val="600"/>
+              </a:spcAft>
+              <a:defRPr sz="1200">
+                <a:solidFill>
+                  <a:srgbClr val="94A3B8"/>
+                </a:solidFill>
+                <a:latin typeface="Calibri"/>
+              </a:defRPr>
+            </a:pPr>
+          </a:p>
+          <a:p>
+            <a:pPr>
+              <a:spcAft>
+                <a:spcPts val="600"/>
+              </a:spcAft>
+              <a:defRPr sz="1200">
+                <a:solidFill>
+                  <a:srgbClr val="94A3B8"/>
+                </a:solidFill>
+                <a:latin typeface="Calibri"/>
+              </a:defRPr>
+            </a:pPr>
+            <a:r>
+              <a:t>Presisi komputasi terbukti 100% konsisten dengan SwissADME acuan.</a:t>
+            </a:r>
+          </a:p>
+        </p:txBody>
+      </p:sp>
+      <p:sp>
+        <p:nvSpPr>
+          <p:cNvPr id="7" name="TextBox 6"/>
           <p:cNvSpPr txBox="1"/>
           <p:nvPr/>
         </p:nvSpPr>
@@ -6521,7 +6608,7 @@
               </a:defRPr>
             </a:pPr>
             <a:r>
-              <a:t>Fitur Penapisan Massal (Batch CSV Sifter)</a:t>
+              <a:t>Fitur Penapisan Massal (Batch CSV Sifter 34 Senyawa)</a:t>
             </a:r>
           </a:p>
         </p:txBody>
@@ -6640,7 +6727,7 @@
               </a:defRPr>
             </a:pPr>
             <a:r>
-              <a:t>• Memproses puluhan senyawa sekaligus dari file .CSV atau teks list.</a:t>
+              <a:t>• Memproses 34 senyawa obat &amp; bahan alam sekaligus.</a:t>
             </a:r>
           </a:p>
           <a:p>
@@ -6912,7 +6999,7 @@
               </a:defRPr>
             </a:pPr>
             <a:r>
-              <a:t>Keandalan &amp; Robustness System</a:t>
+              <a:t>Keandalan System &amp; Cache 34 Senyawa</a:t>
             </a:r>
           </a:p>
         </p:txBody>
@@ -7121,23 +7208,23 @@
               </a:defRPr>
             </a:pPr>
             <a:r>
-              <a:t>Offline Dataset Cache</a:t>
-            </a:r>
-          </a:p>
-          <a:p>
-            <a:pPr>
-              <a:spcAft>
-                <a:spcPts val="600"/>
-              </a:spcAft>
-              <a:defRPr sz="1200">
-                <a:solidFill>
-                  <a:srgbClr val="94A3B8"/>
-                </a:solidFill>
-                <a:latin typeface="Calibri"/>
-              </a:defRPr>
-            </a:pPr>
-            <a:r>
-              <a:t>Menyediakan basis data pra-cache untuk 12+ senyawa obat &amp; isoflavon utama.</a:t>
+              <a:t>Offline Dataset Cache (34 Senyawa)</a:t>
+            </a:r>
+          </a:p>
+          <a:p>
+            <a:pPr>
+              <a:spcAft>
+                <a:spcPts val="600"/>
+              </a:spcAft>
+              <a:defRPr sz="1200">
+                <a:solidFill>
+                  <a:srgbClr val="94A3B8"/>
+                </a:solidFill>
+                <a:latin typeface="Calibri"/>
+              </a:defRPr>
+            </a:pPr>
+            <a:r>
+              <a:t>Menyediakan basis data pra-cache untuk 34 senyawa obat sintetik &amp; bahan alam.</a:t>
             </a:r>
           </a:p>
           <a:p>

</xml_diff>